<commit_message>
Update Introduction to Fourier Neural Operators.pptx
</commit_message>
<xml_diff>
--- a/Introduction to Fourier Neural Operators.pptx
+++ b/Introduction to Fourier Neural Operators.pptx
@@ -16,6 +16,7 @@
     <p:sldId id="263" r:id="rId10"/>
     <p:sldId id="264" r:id="rId11"/>
     <p:sldId id="265" r:id="rId12"/>
+    <p:sldId id="268" r:id="rId13"/>
   </p:sldIdLst>
   <p:sldSz cx="12192000" cy="6858000"/>
   <p:notesSz cx="6858000" cy="9144000"/>
@@ -3479,8 +3480,8 @@
           </a:p>
         </p:txBody>
       </p:sp>
-      <mc:AlternateContent xmlns:mc="http://schemas.openxmlformats.org/markup-compatibility/2006" xmlns:a14="http://schemas.microsoft.com/office/drawing/2010/main">
-        <mc:Choice Requires="a14">
+      <mc:AlternateContent xmlns:mc="http://schemas.openxmlformats.org/markup-compatibility/2006">
+        <mc:Choice xmlns:a14="http://schemas.microsoft.com/office/drawing/2010/main" Requires="a14">
           <p:sp>
             <p:nvSpPr>
               <p:cNvPr id="3" name="Content Placeholder 2">
@@ -3631,7 +3632,15 @@
                 </a14:m>
                 <a:r>
                   <a:rPr lang="en-US" b="0" dirty="0"/>
-                  <a:t>, truncating analytic solution to Navier-Stokes gives 2% error</a:t>
+                  <a:t>, truncating analytic solution to </a:t>
+                </a:r>
+                <a:r>
+                  <a:rPr lang="en-US" dirty="0"/>
+                  <a:t>20 modes </a:t>
+                </a:r>
+                <a:r>
+                  <a:rPr lang="en-US" b="0" dirty="0"/>
+                  <a:t>gives 2% error</a:t>
                 </a:r>
               </a:p>
               <a:p>
@@ -3753,7 +3762,7 @@
             </p:txBody>
           </p:sp>
         </mc:Choice>
-        <mc:Fallback xmlns="">
+        <mc:Fallback>
           <p:sp>
             <p:nvSpPr>
               <p:cNvPr id="3" name="Content Placeholder 2">
@@ -3803,6 +3812,385 @@
   <p:clrMapOvr>
     <a:masterClrMapping/>
   </p:clrMapOvr>
+  <p:timing>
+    <p:tnLst>
+      <p:par>
+        <p:cTn id="1" dur="indefinite" restart="never" nodeType="tmRoot">
+          <p:childTnLst>
+            <p:seq concurrent="1" nextAc="seek">
+              <p:cTn id="2" dur="indefinite" nodeType="mainSeq">
+                <p:childTnLst>
+                  <p:par>
+                    <p:cTn id="3" fill="hold">
+                      <p:stCondLst>
+                        <p:cond delay="indefinite"/>
+                      </p:stCondLst>
+                      <p:childTnLst>
+                        <p:par>
+                          <p:cTn id="4" fill="hold">
+                            <p:stCondLst>
+                              <p:cond delay="0"/>
+                            </p:stCondLst>
+                            <p:childTnLst>
+                              <p:par>
+                                <p:cTn id="5" presetID="1" presetClass="entr" presetSubtype="0" fill="hold" grpId="0" nodeType="clickEffect">
+                                  <p:stCondLst>
+                                    <p:cond delay="0"/>
+                                  </p:stCondLst>
+                                  <p:childTnLst>
+                                    <p:set>
+                                      <p:cBhvr>
+                                        <p:cTn id="6" dur="1" fill="hold">
+                                          <p:stCondLst>
+                                            <p:cond delay="0"/>
+                                          </p:stCondLst>
+                                        </p:cTn>
+                                        <p:tgtEl>
+                                          <p:spTgt spid="3">
+                                            <p:txEl>
+                                              <p:pRg st="0" end="0"/>
+                                            </p:txEl>
+                                          </p:spTgt>
+                                        </p:tgtEl>
+                                        <p:attrNameLst>
+                                          <p:attrName>style.visibility</p:attrName>
+                                        </p:attrNameLst>
+                                      </p:cBhvr>
+                                      <p:to>
+                                        <p:strVal val="visible"/>
+                                      </p:to>
+                                    </p:set>
+                                  </p:childTnLst>
+                                </p:cTn>
+                              </p:par>
+                              <p:par>
+                                <p:cTn id="7" presetID="1" presetClass="entr" presetSubtype="0" fill="hold" grpId="0" nodeType="withEffect">
+                                  <p:stCondLst>
+                                    <p:cond delay="0"/>
+                                  </p:stCondLst>
+                                  <p:childTnLst>
+                                    <p:set>
+                                      <p:cBhvr>
+                                        <p:cTn id="8" dur="1" fill="hold">
+                                          <p:stCondLst>
+                                            <p:cond delay="0"/>
+                                          </p:stCondLst>
+                                        </p:cTn>
+                                        <p:tgtEl>
+                                          <p:spTgt spid="3">
+                                            <p:txEl>
+                                              <p:pRg st="1" end="1"/>
+                                            </p:txEl>
+                                          </p:spTgt>
+                                        </p:tgtEl>
+                                        <p:attrNameLst>
+                                          <p:attrName>style.visibility</p:attrName>
+                                        </p:attrNameLst>
+                                      </p:cBhvr>
+                                      <p:to>
+                                        <p:strVal val="visible"/>
+                                      </p:to>
+                                    </p:set>
+                                  </p:childTnLst>
+                                </p:cTn>
+                              </p:par>
+                              <p:par>
+                                <p:cTn id="9" presetID="1" presetClass="entr" presetSubtype="0" fill="hold" grpId="0" nodeType="withEffect">
+                                  <p:stCondLst>
+                                    <p:cond delay="0"/>
+                                  </p:stCondLst>
+                                  <p:childTnLst>
+                                    <p:set>
+                                      <p:cBhvr>
+                                        <p:cTn id="10" dur="1" fill="hold">
+                                          <p:stCondLst>
+                                            <p:cond delay="0"/>
+                                          </p:stCondLst>
+                                        </p:cTn>
+                                        <p:tgtEl>
+                                          <p:spTgt spid="3">
+                                            <p:txEl>
+                                              <p:pRg st="2" end="2"/>
+                                            </p:txEl>
+                                          </p:spTgt>
+                                        </p:tgtEl>
+                                        <p:attrNameLst>
+                                          <p:attrName>style.visibility</p:attrName>
+                                        </p:attrNameLst>
+                                      </p:cBhvr>
+                                      <p:to>
+                                        <p:strVal val="visible"/>
+                                      </p:to>
+                                    </p:set>
+                                  </p:childTnLst>
+                                </p:cTn>
+                              </p:par>
+                              <p:par>
+                                <p:cTn id="11" presetID="1" presetClass="entr" presetSubtype="0" fill="hold" grpId="0" nodeType="withEffect">
+                                  <p:stCondLst>
+                                    <p:cond delay="0"/>
+                                  </p:stCondLst>
+                                  <p:childTnLst>
+                                    <p:set>
+                                      <p:cBhvr>
+                                        <p:cTn id="12" dur="1" fill="hold">
+                                          <p:stCondLst>
+                                            <p:cond delay="0"/>
+                                          </p:stCondLst>
+                                        </p:cTn>
+                                        <p:tgtEl>
+                                          <p:spTgt spid="3">
+                                            <p:txEl>
+                                              <p:pRg st="3" end="3"/>
+                                            </p:txEl>
+                                          </p:spTgt>
+                                        </p:tgtEl>
+                                        <p:attrNameLst>
+                                          <p:attrName>style.visibility</p:attrName>
+                                        </p:attrNameLst>
+                                      </p:cBhvr>
+                                      <p:to>
+                                        <p:strVal val="visible"/>
+                                      </p:to>
+                                    </p:set>
+                                  </p:childTnLst>
+                                </p:cTn>
+                              </p:par>
+                              <p:par>
+                                <p:cTn id="13" presetID="1" presetClass="entr" presetSubtype="0" fill="hold" grpId="0" nodeType="withEffect">
+                                  <p:stCondLst>
+                                    <p:cond delay="0"/>
+                                  </p:stCondLst>
+                                  <p:childTnLst>
+                                    <p:set>
+                                      <p:cBhvr>
+                                        <p:cTn id="14" dur="1" fill="hold">
+                                          <p:stCondLst>
+                                            <p:cond delay="0"/>
+                                          </p:stCondLst>
+                                        </p:cTn>
+                                        <p:tgtEl>
+                                          <p:spTgt spid="3">
+                                            <p:txEl>
+                                              <p:pRg st="4" end="4"/>
+                                            </p:txEl>
+                                          </p:spTgt>
+                                        </p:tgtEl>
+                                        <p:attrNameLst>
+                                          <p:attrName>style.visibility</p:attrName>
+                                        </p:attrNameLst>
+                                      </p:cBhvr>
+                                      <p:to>
+                                        <p:strVal val="visible"/>
+                                      </p:to>
+                                    </p:set>
+                                  </p:childTnLst>
+                                </p:cTn>
+                              </p:par>
+                            </p:childTnLst>
+                          </p:cTn>
+                        </p:par>
+                      </p:childTnLst>
+                    </p:cTn>
+                  </p:par>
+                  <p:par>
+                    <p:cTn id="15" fill="hold">
+                      <p:stCondLst>
+                        <p:cond delay="indefinite"/>
+                      </p:stCondLst>
+                      <p:childTnLst>
+                        <p:par>
+                          <p:cTn id="16" fill="hold">
+                            <p:stCondLst>
+                              <p:cond delay="0"/>
+                            </p:stCondLst>
+                            <p:childTnLst>
+                              <p:par>
+                                <p:cTn id="17" presetID="1" presetClass="entr" presetSubtype="0" fill="hold" grpId="0" nodeType="clickEffect">
+                                  <p:stCondLst>
+                                    <p:cond delay="0"/>
+                                  </p:stCondLst>
+                                  <p:childTnLst>
+                                    <p:set>
+                                      <p:cBhvr>
+                                        <p:cTn id="18" dur="1" fill="hold">
+                                          <p:stCondLst>
+                                            <p:cond delay="0"/>
+                                          </p:stCondLst>
+                                        </p:cTn>
+                                        <p:tgtEl>
+                                          <p:spTgt spid="3">
+                                            <p:txEl>
+                                              <p:pRg st="6" end="6"/>
+                                            </p:txEl>
+                                          </p:spTgt>
+                                        </p:tgtEl>
+                                        <p:attrNameLst>
+                                          <p:attrName>style.visibility</p:attrName>
+                                        </p:attrNameLst>
+                                      </p:cBhvr>
+                                      <p:to>
+                                        <p:strVal val="visible"/>
+                                      </p:to>
+                                    </p:set>
+                                  </p:childTnLst>
+                                </p:cTn>
+                              </p:par>
+                              <p:par>
+                                <p:cTn id="19" presetID="1" presetClass="entr" presetSubtype="0" fill="hold" grpId="0" nodeType="withEffect">
+                                  <p:stCondLst>
+                                    <p:cond delay="0"/>
+                                  </p:stCondLst>
+                                  <p:childTnLst>
+                                    <p:set>
+                                      <p:cBhvr>
+                                        <p:cTn id="20" dur="1" fill="hold">
+                                          <p:stCondLst>
+                                            <p:cond delay="0"/>
+                                          </p:stCondLst>
+                                        </p:cTn>
+                                        <p:tgtEl>
+                                          <p:spTgt spid="3">
+                                            <p:txEl>
+                                              <p:pRg st="7" end="7"/>
+                                            </p:txEl>
+                                          </p:spTgt>
+                                        </p:tgtEl>
+                                        <p:attrNameLst>
+                                          <p:attrName>style.visibility</p:attrName>
+                                        </p:attrNameLst>
+                                      </p:cBhvr>
+                                      <p:to>
+                                        <p:strVal val="visible"/>
+                                      </p:to>
+                                    </p:set>
+                                  </p:childTnLst>
+                                </p:cTn>
+                              </p:par>
+                              <p:par>
+                                <p:cTn id="21" presetID="1" presetClass="entr" presetSubtype="0" fill="hold" grpId="0" nodeType="withEffect">
+                                  <p:stCondLst>
+                                    <p:cond delay="0"/>
+                                  </p:stCondLst>
+                                  <p:childTnLst>
+                                    <p:set>
+                                      <p:cBhvr>
+                                        <p:cTn id="22" dur="1" fill="hold">
+                                          <p:stCondLst>
+                                            <p:cond delay="0"/>
+                                          </p:stCondLst>
+                                        </p:cTn>
+                                        <p:tgtEl>
+                                          <p:spTgt spid="3">
+                                            <p:txEl>
+                                              <p:pRg st="8" end="8"/>
+                                            </p:txEl>
+                                          </p:spTgt>
+                                        </p:tgtEl>
+                                        <p:attrNameLst>
+                                          <p:attrName>style.visibility</p:attrName>
+                                        </p:attrNameLst>
+                                      </p:cBhvr>
+                                      <p:to>
+                                        <p:strVal val="visible"/>
+                                      </p:to>
+                                    </p:set>
+                                  </p:childTnLst>
+                                </p:cTn>
+                              </p:par>
+                              <p:par>
+                                <p:cTn id="23" presetID="1" presetClass="entr" presetSubtype="0" fill="hold" grpId="0" nodeType="withEffect">
+                                  <p:stCondLst>
+                                    <p:cond delay="0"/>
+                                  </p:stCondLst>
+                                  <p:childTnLst>
+                                    <p:set>
+                                      <p:cBhvr>
+                                        <p:cTn id="24" dur="1" fill="hold">
+                                          <p:stCondLst>
+                                            <p:cond delay="0"/>
+                                          </p:stCondLst>
+                                        </p:cTn>
+                                        <p:tgtEl>
+                                          <p:spTgt spid="3">
+                                            <p:txEl>
+                                              <p:pRg st="9" end="9"/>
+                                            </p:txEl>
+                                          </p:spTgt>
+                                        </p:tgtEl>
+                                        <p:attrNameLst>
+                                          <p:attrName>style.visibility</p:attrName>
+                                        </p:attrNameLst>
+                                      </p:cBhvr>
+                                      <p:to>
+                                        <p:strVal val="visible"/>
+                                      </p:to>
+                                    </p:set>
+                                  </p:childTnLst>
+                                </p:cTn>
+                              </p:par>
+                              <p:par>
+                                <p:cTn id="25" presetID="1" presetClass="entr" presetSubtype="0" fill="hold" grpId="0" nodeType="withEffect">
+                                  <p:stCondLst>
+                                    <p:cond delay="0"/>
+                                  </p:stCondLst>
+                                  <p:childTnLst>
+                                    <p:set>
+                                      <p:cBhvr>
+                                        <p:cTn id="26" dur="1" fill="hold">
+                                          <p:stCondLst>
+                                            <p:cond delay="0"/>
+                                          </p:stCondLst>
+                                        </p:cTn>
+                                        <p:tgtEl>
+                                          <p:spTgt spid="3">
+                                            <p:txEl>
+                                              <p:pRg st="10" end="10"/>
+                                            </p:txEl>
+                                          </p:spTgt>
+                                        </p:tgtEl>
+                                        <p:attrNameLst>
+                                          <p:attrName>style.visibility</p:attrName>
+                                        </p:attrNameLst>
+                                      </p:cBhvr>
+                                      <p:to>
+                                        <p:strVal val="visible"/>
+                                      </p:to>
+                                    </p:set>
+                                  </p:childTnLst>
+                                </p:cTn>
+                              </p:par>
+                            </p:childTnLst>
+                          </p:cTn>
+                        </p:par>
+                      </p:childTnLst>
+                    </p:cTn>
+                  </p:par>
+                </p:childTnLst>
+              </p:cTn>
+              <p:prevCondLst>
+                <p:cond evt="onPrev" delay="0">
+                  <p:tgtEl>
+                    <p:sldTgt/>
+                  </p:tgtEl>
+                </p:cond>
+              </p:prevCondLst>
+              <p:nextCondLst>
+                <p:cond evt="onNext" delay="0">
+                  <p:tgtEl>
+                    <p:sldTgt/>
+                  </p:tgtEl>
+                </p:cond>
+              </p:nextCondLst>
+            </p:seq>
+          </p:childTnLst>
+        </p:cTn>
+      </p:par>
+    </p:tnLst>
+    <p:bldLst>
+      <p:bldP spid="3" grpId="0" build="p"/>
+    </p:bldLst>
+  </p:timing>
 </p:sld>
 </file>
 
@@ -4110,6 +4498,387 @@
     <p:extLst>
       <p:ext uri="{BB962C8B-B14F-4D97-AF65-F5344CB8AC3E}">
         <p14:creationId xmlns:p14="http://schemas.microsoft.com/office/powerpoint/2010/main" val="2523531511"/>
+      </p:ext>
+    </p:extLst>
+  </p:cSld>
+  <p:clrMapOvr>
+    <a:masterClrMapping/>
+  </p:clrMapOvr>
+  <p:timing>
+    <p:tnLst>
+      <p:par>
+        <p:cTn id="1" dur="indefinite" restart="never" nodeType="tmRoot">
+          <p:childTnLst>
+            <p:seq concurrent="1" nextAc="seek">
+              <p:cTn id="2" dur="indefinite" nodeType="mainSeq">
+                <p:childTnLst>
+                  <p:par>
+                    <p:cTn id="3" fill="hold">
+                      <p:stCondLst>
+                        <p:cond delay="indefinite"/>
+                      </p:stCondLst>
+                      <p:childTnLst>
+                        <p:par>
+                          <p:cTn id="4" fill="hold">
+                            <p:stCondLst>
+                              <p:cond delay="0"/>
+                            </p:stCondLst>
+                            <p:childTnLst>
+                              <p:par>
+                                <p:cTn id="5" presetID="1" presetClass="entr" presetSubtype="0" fill="hold" grpId="0" nodeType="clickEffect">
+                                  <p:stCondLst>
+                                    <p:cond delay="0"/>
+                                  </p:stCondLst>
+                                  <p:childTnLst>
+                                    <p:set>
+                                      <p:cBhvr>
+                                        <p:cTn id="6" dur="1" fill="hold">
+                                          <p:stCondLst>
+                                            <p:cond delay="0"/>
+                                          </p:stCondLst>
+                                        </p:cTn>
+                                        <p:tgtEl>
+                                          <p:spTgt spid="3">
+                                            <p:txEl>
+                                              <p:pRg st="0" end="0"/>
+                                            </p:txEl>
+                                          </p:spTgt>
+                                        </p:tgtEl>
+                                        <p:attrNameLst>
+                                          <p:attrName>style.visibility</p:attrName>
+                                        </p:attrNameLst>
+                                      </p:cBhvr>
+                                      <p:to>
+                                        <p:strVal val="visible"/>
+                                      </p:to>
+                                    </p:set>
+                                  </p:childTnLst>
+                                </p:cTn>
+                              </p:par>
+                              <p:par>
+                                <p:cTn id="7" presetID="1" presetClass="entr" presetSubtype="0" fill="hold" grpId="0" nodeType="withEffect">
+                                  <p:stCondLst>
+                                    <p:cond delay="0"/>
+                                  </p:stCondLst>
+                                  <p:childTnLst>
+                                    <p:set>
+                                      <p:cBhvr>
+                                        <p:cTn id="8" dur="1" fill="hold">
+                                          <p:stCondLst>
+                                            <p:cond delay="0"/>
+                                          </p:stCondLst>
+                                        </p:cTn>
+                                        <p:tgtEl>
+                                          <p:spTgt spid="3">
+                                            <p:txEl>
+                                              <p:pRg st="1" end="1"/>
+                                            </p:txEl>
+                                          </p:spTgt>
+                                        </p:tgtEl>
+                                        <p:attrNameLst>
+                                          <p:attrName>style.visibility</p:attrName>
+                                        </p:attrNameLst>
+                                      </p:cBhvr>
+                                      <p:to>
+                                        <p:strVal val="visible"/>
+                                      </p:to>
+                                    </p:set>
+                                  </p:childTnLst>
+                                </p:cTn>
+                              </p:par>
+                              <p:par>
+                                <p:cTn id="9" presetID="1" presetClass="entr" presetSubtype="0" fill="hold" grpId="0" nodeType="withEffect">
+                                  <p:stCondLst>
+                                    <p:cond delay="0"/>
+                                  </p:stCondLst>
+                                  <p:childTnLst>
+                                    <p:set>
+                                      <p:cBhvr>
+                                        <p:cTn id="10" dur="1" fill="hold">
+                                          <p:stCondLst>
+                                            <p:cond delay="0"/>
+                                          </p:stCondLst>
+                                        </p:cTn>
+                                        <p:tgtEl>
+                                          <p:spTgt spid="3">
+                                            <p:txEl>
+                                              <p:pRg st="2" end="2"/>
+                                            </p:txEl>
+                                          </p:spTgt>
+                                        </p:tgtEl>
+                                        <p:attrNameLst>
+                                          <p:attrName>style.visibility</p:attrName>
+                                        </p:attrNameLst>
+                                      </p:cBhvr>
+                                      <p:to>
+                                        <p:strVal val="visible"/>
+                                      </p:to>
+                                    </p:set>
+                                  </p:childTnLst>
+                                </p:cTn>
+                              </p:par>
+                            </p:childTnLst>
+                          </p:cTn>
+                        </p:par>
+                      </p:childTnLst>
+                    </p:cTn>
+                  </p:par>
+                  <p:par>
+                    <p:cTn id="11" fill="hold">
+                      <p:stCondLst>
+                        <p:cond delay="indefinite"/>
+                      </p:stCondLst>
+                      <p:childTnLst>
+                        <p:par>
+                          <p:cTn id="12" fill="hold">
+                            <p:stCondLst>
+                              <p:cond delay="0"/>
+                            </p:stCondLst>
+                            <p:childTnLst>
+                              <p:par>
+                                <p:cTn id="13" presetID="1" presetClass="entr" presetSubtype="0" fill="hold" grpId="0" nodeType="clickEffect">
+                                  <p:stCondLst>
+                                    <p:cond delay="0"/>
+                                  </p:stCondLst>
+                                  <p:childTnLst>
+                                    <p:set>
+                                      <p:cBhvr>
+                                        <p:cTn id="14" dur="1" fill="hold">
+                                          <p:stCondLst>
+                                            <p:cond delay="0"/>
+                                          </p:stCondLst>
+                                        </p:cTn>
+                                        <p:tgtEl>
+                                          <p:spTgt spid="3">
+                                            <p:txEl>
+                                              <p:pRg st="4" end="4"/>
+                                            </p:txEl>
+                                          </p:spTgt>
+                                        </p:tgtEl>
+                                        <p:attrNameLst>
+                                          <p:attrName>style.visibility</p:attrName>
+                                        </p:attrNameLst>
+                                      </p:cBhvr>
+                                      <p:to>
+                                        <p:strVal val="visible"/>
+                                      </p:to>
+                                    </p:set>
+                                  </p:childTnLst>
+                                </p:cTn>
+                              </p:par>
+                              <p:par>
+                                <p:cTn id="15" presetID="1" presetClass="entr" presetSubtype="0" fill="hold" grpId="0" nodeType="withEffect">
+                                  <p:stCondLst>
+                                    <p:cond delay="0"/>
+                                  </p:stCondLst>
+                                  <p:childTnLst>
+                                    <p:set>
+                                      <p:cBhvr>
+                                        <p:cTn id="16" dur="1" fill="hold">
+                                          <p:stCondLst>
+                                            <p:cond delay="0"/>
+                                          </p:stCondLst>
+                                        </p:cTn>
+                                        <p:tgtEl>
+                                          <p:spTgt spid="3">
+                                            <p:txEl>
+                                              <p:pRg st="5" end="5"/>
+                                            </p:txEl>
+                                          </p:spTgt>
+                                        </p:tgtEl>
+                                        <p:attrNameLst>
+                                          <p:attrName>style.visibility</p:attrName>
+                                        </p:attrNameLst>
+                                      </p:cBhvr>
+                                      <p:to>
+                                        <p:strVal val="visible"/>
+                                      </p:to>
+                                    </p:set>
+                                  </p:childTnLst>
+                                </p:cTn>
+                              </p:par>
+                              <p:par>
+                                <p:cTn id="17" presetID="1" presetClass="entr" presetSubtype="0" fill="hold" grpId="0" nodeType="withEffect">
+                                  <p:stCondLst>
+                                    <p:cond delay="0"/>
+                                  </p:stCondLst>
+                                  <p:childTnLst>
+                                    <p:set>
+                                      <p:cBhvr>
+                                        <p:cTn id="18" dur="1" fill="hold">
+                                          <p:stCondLst>
+                                            <p:cond delay="0"/>
+                                          </p:stCondLst>
+                                        </p:cTn>
+                                        <p:tgtEl>
+                                          <p:spTgt spid="3">
+                                            <p:txEl>
+                                              <p:pRg st="6" end="6"/>
+                                            </p:txEl>
+                                          </p:spTgt>
+                                        </p:tgtEl>
+                                        <p:attrNameLst>
+                                          <p:attrName>style.visibility</p:attrName>
+                                        </p:attrNameLst>
+                                      </p:cBhvr>
+                                      <p:to>
+                                        <p:strVal val="visible"/>
+                                      </p:to>
+                                    </p:set>
+                                  </p:childTnLst>
+                                </p:cTn>
+                              </p:par>
+                              <p:par>
+                                <p:cTn id="19" presetID="1" presetClass="entr" presetSubtype="0" fill="hold" grpId="0" nodeType="withEffect">
+                                  <p:stCondLst>
+                                    <p:cond delay="0"/>
+                                  </p:stCondLst>
+                                  <p:childTnLst>
+                                    <p:set>
+                                      <p:cBhvr>
+                                        <p:cTn id="20" dur="1" fill="hold">
+                                          <p:stCondLst>
+                                            <p:cond delay="0"/>
+                                          </p:stCondLst>
+                                        </p:cTn>
+                                        <p:tgtEl>
+                                          <p:spTgt spid="3">
+                                            <p:txEl>
+                                              <p:pRg st="7" end="7"/>
+                                            </p:txEl>
+                                          </p:spTgt>
+                                        </p:tgtEl>
+                                        <p:attrNameLst>
+                                          <p:attrName>style.visibility</p:attrName>
+                                        </p:attrNameLst>
+                                      </p:cBhvr>
+                                      <p:to>
+                                        <p:strVal val="visible"/>
+                                      </p:to>
+                                    </p:set>
+                                  </p:childTnLst>
+                                </p:cTn>
+                              </p:par>
+                              <p:par>
+                                <p:cTn id="21" presetID="1" presetClass="entr" presetSubtype="0" fill="hold" grpId="0" nodeType="withEffect">
+                                  <p:stCondLst>
+                                    <p:cond delay="0"/>
+                                  </p:stCondLst>
+                                  <p:childTnLst>
+                                    <p:set>
+                                      <p:cBhvr>
+                                        <p:cTn id="22" dur="1" fill="hold">
+                                          <p:stCondLst>
+                                            <p:cond delay="0"/>
+                                          </p:stCondLst>
+                                        </p:cTn>
+                                        <p:tgtEl>
+                                          <p:spTgt spid="3">
+                                            <p:txEl>
+                                              <p:pRg st="8" end="8"/>
+                                            </p:txEl>
+                                          </p:spTgt>
+                                        </p:tgtEl>
+                                        <p:attrNameLst>
+                                          <p:attrName>style.visibility</p:attrName>
+                                        </p:attrNameLst>
+                                      </p:cBhvr>
+                                      <p:to>
+                                        <p:strVal val="visible"/>
+                                      </p:to>
+                                    </p:set>
+                                  </p:childTnLst>
+                                </p:cTn>
+                              </p:par>
+                            </p:childTnLst>
+                          </p:cTn>
+                        </p:par>
+                      </p:childTnLst>
+                    </p:cTn>
+                  </p:par>
+                </p:childTnLst>
+              </p:cTn>
+              <p:prevCondLst>
+                <p:cond evt="onPrev" delay="0">
+                  <p:tgtEl>
+                    <p:sldTgt/>
+                  </p:tgtEl>
+                </p:cond>
+              </p:prevCondLst>
+              <p:nextCondLst>
+                <p:cond evt="onNext" delay="0">
+                  <p:tgtEl>
+                    <p:sldTgt/>
+                  </p:tgtEl>
+                </p:cond>
+              </p:nextCondLst>
+            </p:seq>
+          </p:childTnLst>
+        </p:cTn>
+      </p:par>
+    </p:tnLst>
+    <p:bldLst>
+      <p:bldP spid="3" grpId="0" build="p"/>
+    </p:bldLst>
+  </p:timing>
+</p:sld>
+</file>
+
+<file path=ppt/slides/slide12.xml><?xml version="1.0" encoding="utf-8"?>
+<p:sld xmlns:a="http://schemas.openxmlformats.org/drawingml/2006/main" xmlns:r="http://schemas.openxmlformats.org/officeDocument/2006/relationships" xmlns:p="http://schemas.openxmlformats.org/presentationml/2006/main">
+  <p:cSld>
+    <p:spTree>
+      <p:nvGrpSpPr>
+        <p:cNvPr id="1" name=""/>
+        <p:cNvGrpSpPr/>
+        <p:nvPr/>
+      </p:nvGrpSpPr>
+      <p:grpSpPr>
+        <a:xfrm>
+          <a:off x="0" y="0"/>
+          <a:ext cx="0" cy="0"/>
+          <a:chOff x="0" y="0"/>
+          <a:chExt cx="0" cy="0"/>
+        </a:xfrm>
+      </p:grpSpPr>
+      <p:sp>
+        <p:nvSpPr>
+          <p:cNvPr id="2" name="Title 1">
+            <a:extLst>
+              <a:ext uri="{FF2B5EF4-FFF2-40B4-BE49-F238E27FC236}">
+                <a16:creationId xmlns:a16="http://schemas.microsoft.com/office/drawing/2014/main" id="{E3DAC9E4-C1D5-885B-5163-F4FF4B83730F}"/>
+              </a:ext>
+            </a:extLst>
+          </p:cNvPr>
+          <p:cNvSpPr>
+            <a:spLocks noGrp="1"/>
+          </p:cNvSpPr>
+          <p:nvPr>
+            <p:ph type="title"/>
+          </p:nvPr>
+        </p:nvSpPr>
+        <p:spPr>
+          <a:xfrm>
+            <a:off x="838200" y="2766218"/>
+            <a:ext cx="10515600" cy="1325563"/>
+          </a:xfrm>
+        </p:spPr>
+        <p:txBody>
+          <a:bodyPr/>
+          <a:lstStyle/>
+          <a:p>
+            <a:pPr algn="ctr"/>
+            <a:r>
+              <a:rPr lang="en-GB" dirty="0"/>
+              <a:t>Thank for listening</a:t>
+            </a:r>
+          </a:p>
+        </p:txBody>
+      </p:sp>
+    </p:spTree>
+    <p:extLst>
+      <p:ext uri="{BB962C8B-B14F-4D97-AF65-F5344CB8AC3E}">
+        <p14:creationId xmlns:p14="http://schemas.microsoft.com/office/powerpoint/2010/main" val="352031487"/>
       </p:ext>
     </p:extLst>
   </p:cSld>
@@ -4916,6 +5685,292 @@
   <p:clrMapOvr>
     <a:masterClrMapping/>
   </p:clrMapOvr>
+  <p:timing>
+    <p:tnLst>
+      <p:par>
+        <p:cTn id="1" dur="indefinite" restart="never" nodeType="tmRoot">
+          <p:childTnLst>
+            <p:seq concurrent="1" nextAc="seek">
+              <p:cTn id="2" dur="indefinite" nodeType="mainSeq">
+                <p:childTnLst>
+                  <p:par>
+                    <p:cTn id="3" fill="hold">
+                      <p:stCondLst>
+                        <p:cond delay="indefinite"/>
+                      </p:stCondLst>
+                      <p:childTnLst>
+                        <p:par>
+                          <p:cTn id="4" fill="hold">
+                            <p:stCondLst>
+                              <p:cond delay="0"/>
+                            </p:stCondLst>
+                            <p:childTnLst>
+                              <p:par>
+                                <p:cTn id="5" presetID="1" presetClass="entr" presetSubtype="0" fill="hold" grpId="0" nodeType="clickEffect">
+                                  <p:stCondLst>
+                                    <p:cond delay="0"/>
+                                  </p:stCondLst>
+                                  <p:childTnLst>
+                                    <p:set>
+                                      <p:cBhvr>
+                                        <p:cTn id="6" dur="1" fill="hold">
+                                          <p:stCondLst>
+                                            <p:cond delay="0"/>
+                                          </p:stCondLst>
+                                        </p:cTn>
+                                        <p:tgtEl>
+                                          <p:spTgt spid="3">
+                                            <p:txEl>
+                                              <p:pRg st="0" end="0"/>
+                                            </p:txEl>
+                                          </p:spTgt>
+                                        </p:tgtEl>
+                                        <p:attrNameLst>
+                                          <p:attrName>style.visibility</p:attrName>
+                                        </p:attrNameLst>
+                                      </p:cBhvr>
+                                      <p:to>
+                                        <p:strVal val="visible"/>
+                                      </p:to>
+                                    </p:set>
+                                  </p:childTnLst>
+                                </p:cTn>
+                              </p:par>
+                              <p:par>
+                                <p:cTn id="7" presetID="1" presetClass="entr" presetSubtype="0" fill="hold" grpId="0" nodeType="withEffect">
+                                  <p:stCondLst>
+                                    <p:cond delay="0"/>
+                                  </p:stCondLst>
+                                  <p:childTnLst>
+                                    <p:set>
+                                      <p:cBhvr>
+                                        <p:cTn id="8" dur="1" fill="hold">
+                                          <p:stCondLst>
+                                            <p:cond delay="0"/>
+                                          </p:stCondLst>
+                                        </p:cTn>
+                                        <p:tgtEl>
+                                          <p:spTgt spid="3">
+                                            <p:txEl>
+                                              <p:pRg st="1" end="1"/>
+                                            </p:txEl>
+                                          </p:spTgt>
+                                        </p:tgtEl>
+                                        <p:attrNameLst>
+                                          <p:attrName>style.visibility</p:attrName>
+                                        </p:attrNameLst>
+                                      </p:cBhvr>
+                                      <p:to>
+                                        <p:strVal val="visible"/>
+                                      </p:to>
+                                    </p:set>
+                                  </p:childTnLst>
+                                </p:cTn>
+                              </p:par>
+                              <p:par>
+                                <p:cTn id="9" presetID="1" presetClass="entr" presetSubtype="0" fill="hold" grpId="0" nodeType="withEffect">
+                                  <p:stCondLst>
+                                    <p:cond delay="0"/>
+                                  </p:stCondLst>
+                                  <p:childTnLst>
+                                    <p:set>
+                                      <p:cBhvr>
+                                        <p:cTn id="10" dur="1" fill="hold">
+                                          <p:stCondLst>
+                                            <p:cond delay="0"/>
+                                          </p:stCondLst>
+                                        </p:cTn>
+                                        <p:tgtEl>
+                                          <p:spTgt spid="3">
+                                            <p:txEl>
+                                              <p:pRg st="2" end="2"/>
+                                            </p:txEl>
+                                          </p:spTgt>
+                                        </p:tgtEl>
+                                        <p:attrNameLst>
+                                          <p:attrName>style.visibility</p:attrName>
+                                        </p:attrNameLst>
+                                      </p:cBhvr>
+                                      <p:to>
+                                        <p:strVal val="visible"/>
+                                      </p:to>
+                                    </p:set>
+                                  </p:childTnLst>
+                                </p:cTn>
+                              </p:par>
+                            </p:childTnLst>
+                          </p:cTn>
+                        </p:par>
+                      </p:childTnLst>
+                    </p:cTn>
+                  </p:par>
+                  <p:par>
+                    <p:cTn id="11" fill="hold">
+                      <p:stCondLst>
+                        <p:cond delay="indefinite"/>
+                      </p:stCondLst>
+                      <p:childTnLst>
+                        <p:par>
+                          <p:cTn id="12" fill="hold">
+                            <p:stCondLst>
+                              <p:cond delay="0"/>
+                            </p:stCondLst>
+                            <p:childTnLst>
+                              <p:par>
+                                <p:cTn id="13" presetID="1" presetClass="entr" presetSubtype="0" fill="hold" grpId="0" nodeType="clickEffect">
+                                  <p:stCondLst>
+                                    <p:cond delay="0"/>
+                                  </p:stCondLst>
+                                  <p:childTnLst>
+                                    <p:set>
+                                      <p:cBhvr>
+                                        <p:cTn id="14" dur="1" fill="hold">
+                                          <p:stCondLst>
+                                            <p:cond delay="0"/>
+                                          </p:stCondLst>
+                                        </p:cTn>
+                                        <p:tgtEl>
+                                          <p:spTgt spid="3">
+                                            <p:txEl>
+                                              <p:pRg st="4" end="4"/>
+                                            </p:txEl>
+                                          </p:spTgt>
+                                        </p:tgtEl>
+                                        <p:attrNameLst>
+                                          <p:attrName>style.visibility</p:attrName>
+                                        </p:attrNameLst>
+                                      </p:cBhvr>
+                                      <p:to>
+                                        <p:strVal val="visible"/>
+                                      </p:to>
+                                    </p:set>
+                                  </p:childTnLst>
+                                </p:cTn>
+                              </p:par>
+                              <p:par>
+                                <p:cTn id="15" presetID="1" presetClass="entr" presetSubtype="0" fill="hold" grpId="0" nodeType="withEffect">
+                                  <p:stCondLst>
+                                    <p:cond delay="0"/>
+                                  </p:stCondLst>
+                                  <p:childTnLst>
+                                    <p:set>
+                                      <p:cBhvr>
+                                        <p:cTn id="16" dur="1" fill="hold">
+                                          <p:stCondLst>
+                                            <p:cond delay="0"/>
+                                          </p:stCondLst>
+                                        </p:cTn>
+                                        <p:tgtEl>
+                                          <p:spTgt spid="3">
+                                            <p:txEl>
+                                              <p:pRg st="5" end="5"/>
+                                            </p:txEl>
+                                          </p:spTgt>
+                                        </p:tgtEl>
+                                        <p:attrNameLst>
+                                          <p:attrName>style.visibility</p:attrName>
+                                        </p:attrNameLst>
+                                      </p:cBhvr>
+                                      <p:to>
+                                        <p:strVal val="visible"/>
+                                      </p:to>
+                                    </p:set>
+                                  </p:childTnLst>
+                                </p:cTn>
+                              </p:par>
+                              <p:par>
+                                <p:cTn id="17" presetID="1" presetClass="entr" presetSubtype="0" fill="hold" grpId="0" nodeType="withEffect">
+                                  <p:stCondLst>
+                                    <p:cond delay="0"/>
+                                  </p:stCondLst>
+                                  <p:childTnLst>
+                                    <p:set>
+                                      <p:cBhvr>
+                                        <p:cTn id="18" dur="1" fill="hold">
+                                          <p:stCondLst>
+                                            <p:cond delay="0"/>
+                                          </p:stCondLst>
+                                        </p:cTn>
+                                        <p:tgtEl>
+                                          <p:spTgt spid="3">
+                                            <p:txEl>
+                                              <p:pRg st="6" end="6"/>
+                                            </p:txEl>
+                                          </p:spTgt>
+                                        </p:tgtEl>
+                                        <p:attrNameLst>
+                                          <p:attrName>style.visibility</p:attrName>
+                                        </p:attrNameLst>
+                                      </p:cBhvr>
+                                      <p:to>
+                                        <p:strVal val="visible"/>
+                                      </p:to>
+                                    </p:set>
+                                  </p:childTnLst>
+                                </p:cTn>
+                              </p:par>
+                              <p:par>
+                                <p:cTn id="19" presetID="1" presetClass="entr" presetSubtype="0" fill="hold" grpId="0" nodeType="withEffect">
+                                  <p:stCondLst>
+                                    <p:cond delay="0"/>
+                                  </p:stCondLst>
+                                  <p:childTnLst>
+                                    <p:set>
+                                      <p:cBhvr>
+                                        <p:cTn id="20" dur="1" fill="hold">
+                                          <p:stCondLst>
+                                            <p:cond delay="0"/>
+                                          </p:stCondLst>
+                                        </p:cTn>
+                                        <p:tgtEl>
+                                          <p:spTgt spid="3">
+                                            <p:txEl>
+                                              <p:pRg st="7" end="7"/>
+                                            </p:txEl>
+                                          </p:spTgt>
+                                        </p:tgtEl>
+                                        <p:attrNameLst>
+                                          <p:attrName>style.visibility</p:attrName>
+                                        </p:attrNameLst>
+                                      </p:cBhvr>
+                                      <p:to>
+                                        <p:strVal val="visible"/>
+                                      </p:to>
+                                    </p:set>
+                                  </p:childTnLst>
+                                </p:cTn>
+                              </p:par>
+                            </p:childTnLst>
+                          </p:cTn>
+                        </p:par>
+                      </p:childTnLst>
+                    </p:cTn>
+                  </p:par>
+                </p:childTnLst>
+              </p:cTn>
+              <p:prevCondLst>
+                <p:cond evt="onPrev" delay="0">
+                  <p:tgtEl>
+                    <p:sldTgt/>
+                  </p:tgtEl>
+                </p:cond>
+              </p:prevCondLst>
+              <p:nextCondLst>
+                <p:cond evt="onNext" delay="0">
+                  <p:tgtEl>
+                    <p:sldTgt/>
+                  </p:tgtEl>
+                </p:cond>
+              </p:nextCondLst>
+            </p:seq>
+          </p:childTnLst>
+        </p:cTn>
+      </p:par>
+    </p:tnLst>
+    <p:bldLst>
+      <p:bldP spid="3" grpId="0" uiExpand="1" build="p"/>
+    </p:bldLst>
+  </p:timing>
 </p:sld>
 </file>
 
@@ -5014,6 +6069,126 @@
   <p:clrMapOvr>
     <a:masterClrMapping/>
   </p:clrMapOvr>
+  <p:timing>
+    <p:tnLst>
+      <p:par>
+        <p:cTn id="1" dur="indefinite" restart="never" nodeType="tmRoot">
+          <p:childTnLst>
+            <p:seq concurrent="1" nextAc="seek">
+              <p:cTn id="2" dur="indefinite" nodeType="mainSeq">
+                <p:childTnLst>
+                  <p:par>
+                    <p:cTn id="3" fill="hold">
+                      <p:stCondLst>
+                        <p:cond delay="indefinite"/>
+                      </p:stCondLst>
+                      <p:childTnLst>
+                        <p:par>
+                          <p:cTn id="4" fill="hold">
+                            <p:stCondLst>
+                              <p:cond delay="0"/>
+                            </p:stCondLst>
+                            <p:childTnLst>
+                              <p:par>
+                                <p:cTn id="5" presetID="1" presetClass="entr" presetSubtype="0" fill="hold" nodeType="clickEffect">
+                                  <p:stCondLst>
+                                    <p:cond delay="0"/>
+                                  </p:stCondLst>
+                                  <p:childTnLst>
+                                    <p:set>
+                                      <p:cBhvr>
+                                        <p:cTn id="6" dur="1" fill="hold">
+                                          <p:stCondLst>
+                                            <p:cond delay="0"/>
+                                          </p:stCondLst>
+                                        </p:cTn>
+                                        <p:tgtEl>
+                                          <p:spTgt spid="3"/>
+                                        </p:tgtEl>
+                                        <p:attrNameLst>
+                                          <p:attrName>style.visibility</p:attrName>
+                                        </p:attrNameLst>
+                                      </p:cBhvr>
+                                      <p:to>
+                                        <p:strVal val="visible"/>
+                                      </p:to>
+                                    </p:set>
+                                  </p:childTnLst>
+                                </p:cTn>
+                              </p:par>
+                            </p:childTnLst>
+                          </p:cTn>
+                        </p:par>
+                      </p:childTnLst>
+                    </p:cTn>
+                  </p:par>
+                  <p:par>
+                    <p:cTn id="7" fill="hold">
+                      <p:stCondLst>
+                        <p:cond delay="indefinite"/>
+                      </p:stCondLst>
+                      <p:childTnLst>
+                        <p:par>
+                          <p:cTn id="8" fill="hold">
+                            <p:stCondLst>
+                              <p:cond delay="0"/>
+                            </p:stCondLst>
+                            <p:childTnLst>
+                              <p:par>
+                                <p:cTn id="9" presetID="1" presetClass="entr" presetSubtype="0" fill="hold" nodeType="clickEffect">
+                                  <p:stCondLst>
+                                    <p:cond delay="0"/>
+                                  </p:stCondLst>
+                                  <p:childTnLst>
+                                    <p:set>
+                                      <p:cBhvr>
+                                        <p:cTn id="10" dur="1" fill="hold">
+                                          <p:stCondLst>
+                                            <p:cond delay="0"/>
+                                          </p:stCondLst>
+                                        </p:cTn>
+                                        <p:tgtEl>
+                                          <p:spTgt spid="5"/>
+                                        </p:tgtEl>
+                                        <p:attrNameLst>
+                                          <p:attrName>style.visibility</p:attrName>
+                                        </p:attrNameLst>
+                                      </p:cBhvr>
+                                      <p:to>
+                                        <p:strVal val="visible"/>
+                                      </p:to>
+                                    </p:set>
+                                  </p:childTnLst>
+                                </p:cTn>
+                              </p:par>
+                            </p:childTnLst>
+                          </p:cTn>
+                        </p:par>
+                      </p:childTnLst>
+                    </p:cTn>
+                  </p:par>
+                </p:childTnLst>
+              </p:cTn>
+              <p:prevCondLst>
+                <p:cond evt="onPrev" delay="0">
+                  <p:tgtEl>
+                    <p:sldTgt/>
+                  </p:tgtEl>
+                </p:cond>
+              </p:prevCondLst>
+              <p:nextCondLst>
+                <p:cond evt="onNext" delay="0">
+                  <p:tgtEl>
+                    <p:sldTgt/>
+                  </p:tgtEl>
+                </p:cond>
+              </p:nextCondLst>
+            </p:seq>
+          </p:childTnLst>
+        </p:cTn>
+      </p:par>
+    </p:tnLst>
+  </p:timing>
 </p:sld>
 </file>
 
@@ -6087,6 +7262,164 @@
   <p:clrMapOvr>
     <a:masterClrMapping/>
   </p:clrMapOvr>
+  <p:timing>
+    <p:tnLst>
+      <p:par>
+        <p:cTn id="1" dur="indefinite" restart="never" nodeType="tmRoot">
+          <p:childTnLst>
+            <p:seq concurrent="1" nextAc="seek">
+              <p:cTn id="2" dur="indefinite" nodeType="mainSeq">
+                <p:childTnLst>
+                  <p:par>
+                    <p:cTn id="3" fill="hold">
+                      <p:stCondLst>
+                        <p:cond delay="indefinite"/>
+                      </p:stCondLst>
+                      <p:childTnLst>
+                        <p:par>
+                          <p:cTn id="4" fill="hold">
+                            <p:stCondLst>
+                              <p:cond delay="0"/>
+                            </p:stCondLst>
+                            <p:childTnLst>
+                              <p:par>
+                                <p:cTn id="5" presetID="1" presetClass="entr" presetSubtype="0" fill="hold" grpId="0" nodeType="clickEffect">
+                                  <p:stCondLst>
+                                    <p:cond delay="0"/>
+                                  </p:stCondLst>
+                                  <p:childTnLst>
+                                    <p:set>
+                                      <p:cBhvr>
+                                        <p:cTn id="6" dur="1" fill="hold">
+                                          <p:stCondLst>
+                                            <p:cond delay="0"/>
+                                          </p:stCondLst>
+                                        </p:cTn>
+                                        <p:tgtEl>
+                                          <p:spTgt spid="3">
+                                            <p:txEl>
+                                              <p:pRg st="0" end="0"/>
+                                            </p:txEl>
+                                          </p:spTgt>
+                                        </p:tgtEl>
+                                        <p:attrNameLst>
+                                          <p:attrName>style.visibility</p:attrName>
+                                        </p:attrNameLst>
+                                      </p:cBhvr>
+                                      <p:to>
+                                        <p:strVal val="visible"/>
+                                      </p:to>
+                                    </p:set>
+                                  </p:childTnLst>
+                                </p:cTn>
+                              </p:par>
+                              <p:par>
+                                <p:cTn id="7" presetID="1" presetClass="entr" presetSubtype="0" fill="hold" nodeType="withEffect">
+                                  <p:stCondLst>
+                                    <p:cond delay="0"/>
+                                  </p:stCondLst>
+                                  <p:childTnLst>
+                                    <p:set>
+                                      <p:cBhvr>
+                                        <p:cTn id="8" dur="1" fill="hold">
+                                          <p:stCondLst>
+                                            <p:cond delay="0"/>
+                                          </p:stCondLst>
+                                        </p:cTn>
+                                        <p:tgtEl>
+                                          <p:spTgt spid="4"/>
+                                        </p:tgtEl>
+                                        <p:attrNameLst>
+                                          <p:attrName>style.visibility</p:attrName>
+                                        </p:attrNameLst>
+                                      </p:cBhvr>
+                                      <p:to>
+                                        <p:strVal val="visible"/>
+                                      </p:to>
+                                    </p:set>
+                                  </p:childTnLst>
+                                </p:cTn>
+                              </p:par>
+                            </p:childTnLst>
+                          </p:cTn>
+                        </p:par>
+                      </p:childTnLst>
+                    </p:cTn>
+                  </p:par>
+                  <p:par>
+                    <p:cTn id="9" fill="hold">
+                      <p:stCondLst>
+                        <p:cond delay="indefinite"/>
+                      </p:stCondLst>
+                      <p:childTnLst>
+                        <p:par>
+                          <p:cTn id="10" fill="hold">
+                            <p:stCondLst>
+                              <p:cond delay="0"/>
+                            </p:stCondLst>
+                            <p:childTnLst>
+                              <p:par>
+                                <p:cTn id="11" presetID="1" presetClass="entr" presetSubtype="0" fill="hold" grpId="0" nodeType="clickEffect">
+                                  <p:stCondLst>
+                                    <p:cond delay="0"/>
+                                  </p:stCondLst>
+                                  <p:childTnLst>
+                                    <p:set>
+                                      <p:cBhvr>
+                                        <p:cTn id="12" dur="1" fill="hold">
+                                          <p:stCondLst>
+                                            <p:cond delay="0"/>
+                                          </p:stCondLst>
+                                        </p:cTn>
+                                        <p:tgtEl>
+                                          <p:spTgt spid="3">
+                                            <p:txEl>
+                                              <p:pRg st="6" end="6"/>
+                                            </p:txEl>
+                                          </p:spTgt>
+                                        </p:tgtEl>
+                                        <p:attrNameLst>
+                                          <p:attrName>style.visibility</p:attrName>
+                                        </p:attrNameLst>
+                                      </p:cBhvr>
+                                      <p:to>
+                                        <p:strVal val="visible"/>
+                                      </p:to>
+                                    </p:set>
+                                  </p:childTnLst>
+                                </p:cTn>
+                              </p:par>
+                            </p:childTnLst>
+                          </p:cTn>
+                        </p:par>
+                      </p:childTnLst>
+                    </p:cTn>
+                  </p:par>
+                </p:childTnLst>
+              </p:cTn>
+              <p:prevCondLst>
+                <p:cond evt="onPrev" delay="0">
+                  <p:tgtEl>
+                    <p:sldTgt/>
+                  </p:tgtEl>
+                </p:cond>
+              </p:prevCondLst>
+              <p:nextCondLst>
+                <p:cond evt="onNext" delay="0">
+                  <p:tgtEl>
+                    <p:sldTgt/>
+                  </p:tgtEl>
+                </p:cond>
+              </p:nextCondLst>
+            </p:seq>
+          </p:childTnLst>
+        </p:cTn>
+      </p:par>
+    </p:tnLst>
+    <p:bldLst>
+      <p:bldP spid="3" grpId="0" uiExpand="1" build="p"/>
+    </p:bldLst>
+  </p:timing>
 </p:sld>
 </file>
 
@@ -6435,6 +7768,261 @@
   <p:clrMapOvr>
     <a:masterClrMapping/>
   </p:clrMapOvr>
+  <p:timing>
+    <p:tnLst>
+      <p:par>
+        <p:cTn id="1" dur="indefinite" restart="never" nodeType="tmRoot">
+          <p:childTnLst>
+            <p:seq concurrent="1" nextAc="seek">
+              <p:cTn id="2" dur="indefinite" nodeType="mainSeq">
+                <p:childTnLst>
+                  <p:par>
+                    <p:cTn id="3" fill="hold">
+                      <p:stCondLst>
+                        <p:cond delay="indefinite"/>
+                      </p:stCondLst>
+                      <p:childTnLst>
+                        <p:par>
+                          <p:cTn id="4" fill="hold">
+                            <p:stCondLst>
+                              <p:cond delay="0"/>
+                            </p:stCondLst>
+                            <p:childTnLst>
+                              <p:par>
+                                <p:cTn id="5" presetID="1" presetClass="entr" presetSubtype="0" fill="hold" grpId="0" nodeType="clickEffect">
+                                  <p:stCondLst>
+                                    <p:cond delay="0"/>
+                                  </p:stCondLst>
+                                  <p:childTnLst>
+                                    <p:set>
+                                      <p:cBhvr>
+                                        <p:cTn id="6" dur="1" fill="hold">
+                                          <p:stCondLst>
+                                            <p:cond delay="0"/>
+                                          </p:stCondLst>
+                                        </p:cTn>
+                                        <p:tgtEl>
+                                          <p:spTgt spid="3">
+                                            <p:txEl>
+                                              <p:pRg st="0" end="0"/>
+                                            </p:txEl>
+                                          </p:spTgt>
+                                        </p:tgtEl>
+                                        <p:attrNameLst>
+                                          <p:attrName>style.visibility</p:attrName>
+                                        </p:attrNameLst>
+                                      </p:cBhvr>
+                                      <p:to>
+                                        <p:strVal val="visible"/>
+                                      </p:to>
+                                    </p:set>
+                                  </p:childTnLst>
+                                </p:cTn>
+                              </p:par>
+                              <p:par>
+                                <p:cTn id="7" presetID="1" presetClass="entr" presetSubtype="0" fill="hold" grpId="0" nodeType="withEffect">
+                                  <p:stCondLst>
+                                    <p:cond delay="0"/>
+                                  </p:stCondLst>
+                                  <p:childTnLst>
+                                    <p:set>
+                                      <p:cBhvr>
+                                        <p:cTn id="8" dur="1" fill="hold">
+                                          <p:stCondLst>
+                                            <p:cond delay="0"/>
+                                          </p:stCondLst>
+                                        </p:cTn>
+                                        <p:tgtEl>
+                                          <p:spTgt spid="3">
+                                            <p:txEl>
+                                              <p:pRg st="1" end="1"/>
+                                            </p:txEl>
+                                          </p:spTgt>
+                                        </p:tgtEl>
+                                        <p:attrNameLst>
+                                          <p:attrName>style.visibility</p:attrName>
+                                        </p:attrNameLst>
+                                      </p:cBhvr>
+                                      <p:to>
+                                        <p:strVal val="visible"/>
+                                      </p:to>
+                                    </p:set>
+                                  </p:childTnLst>
+                                </p:cTn>
+                              </p:par>
+                              <p:par>
+                                <p:cTn id="9" presetID="1" presetClass="entr" presetSubtype="0" fill="hold" grpId="0" nodeType="withEffect">
+                                  <p:stCondLst>
+                                    <p:cond delay="0"/>
+                                  </p:stCondLst>
+                                  <p:childTnLst>
+                                    <p:set>
+                                      <p:cBhvr>
+                                        <p:cTn id="10" dur="1" fill="hold">
+                                          <p:stCondLst>
+                                            <p:cond delay="0"/>
+                                          </p:stCondLst>
+                                        </p:cTn>
+                                        <p:tgtEl>
+                                          <p:spTgt spid="3">
+                                            <p:txEl>
+                                              <p:pRg st="2" end="2"/>
+                                            </p:txEl>
+                                          </p:spTgt>
+                                        </p:tgtEl>
+                                        <p:attrNameLst>
+                                          <p:attrName>style.visibility</p:attrName>
+                                        </p:attrNameLst>
+                                      </p:cBhvr>
+                                      <p:to>
+                                        <p:strVal val="visible"/>
+                                      </p:to>
+                                    </p:set>
+                                  </p:childTnLst>
+                                </p:cTn>
+                              </p:par>
+                            </p:childTnLst>
+                          </p:cTn>
+                        </p:par>
+                      </p:childTnLst>
+                    </p:cTn>
+                  </p:par>
+                  <p:par>
+                    <p:cTn id="11" fill="hold">
+                      <p:stCondLst>
+                        <p:cond delay="indefinite"/>
+                      </p:stCondLst>
+                      <p:childTnLst>
+                        <p:par>
+                          <p:cTn id="12" fill="hold">
+                            <p:stCondLst>
+                              <p:cond delay="0"/>
+                            </p:stCondLst>
+                            <p:childTnLst>
+                              <p:par>
+                                <p:cTn id="13" presetID="1" presetClass="entr" presetSubtype="0" fill="hold" grpId="0" nodeType="clickEffect">
+                                  <p:stCondLst>
+                                    <p:cond delay="0"/>
+                                  </p:stCondLst>
+                                  <p:childTnLst>
+                                    <p:set>
+                                      <p:cBhvr>
+                                        <p:cTn id="14" dur="1" fill="hold">
+                                          <p:stCondLst>
+                                            <p:cond delay="0"/>
+                                          </p:stCondLst>
+                                        </p:cTn>
+                                        <p:tgtEl>
+                                          <p:spTgt spid="3">
+                                            <p:txEl>
+                                              <p:pRg st="4" end="4"/>
+                                            </p:txEl>
+                                          </p:spTgt>
+                                        </p:tgtEl>
+                                        <p:attrNameLst>
+                                          <p:attrName>style.visibility</p:attrName>
+                                        </p:attrNameLst>
+                                      </p:cBhvr>
+                                      <p:to>
+                                        <p:strVal val="visible"/>
+                                      </p:to>
+                                    </p:set>
+                                  </p:childTnLst>
+                                </p:cTn>
+                              </p:par>
+                              <p:par>
+                                <p:cTn id="15" presetID="1" presetClass="entr" presetSubtype="0" fill="hold" grpId="0" nodeType="withEffect">
+                                  <p:stCondLst>
+                                    <p:cond delay="0"/>
+                                  </p:stCondLst>
+                                  <p:childTnLst>
+                                    <p:set>
+                                      <p:cBhvr>
+                                        <p:cTn id="16" dur="1" fill="hold">
+                                          <p:stCondLst>
+                                            <p:cond delay="0"/>
+                                          </p:stCondLst>
+                                        </p:cTn>
+                                        <p:tgtEl>
+                                          <p:spTgt spid="3">
+                                            <p:txEl>
+                                              <p:pRg st="5" end="5"/>
+                                            </p:txEl>
+                                          </p:spTgt>
+                                        </p:tgtEl>
+                                        <p:attrNameLst>
+                                          <p:attrName>style.visibility</p:attrName>
+                                        </p:attrNameLst>
+                                      </p:cBhvr>
+                                      <p:to>
+                                        <p:strVal val="visible"/>
+                                      </p:to>
+                                    </p:set>
+                                  </p:childTnLst>
+                                </p:cTn>
+                              </p:par>
+                              <p:par>
+                                <p:cTn id="17" presetID="1" presetClass="entr" presetSubtype="0" fill="hold" grpId="0" nodeType="withEffect">
+                                  <p:stCondLst>
+                                    <p:cond delay="0"/>
+                                  </p:stCondLst>
+                                  <p:childTnLst>
+                                    <p:set>
+                                      <p:cBhvr>
+                                        <p:cTn id="18" dur="1" fill="hold">
+                                          <p:stCondLst>
+                                            <p:cond delay="0"/>
+                                          </p:stCondLst>
+                                        </p:cTn>
+                                        <p:tgtEl>
+                                          <p:spTgt spid="3">
+                                            <p:txEl>
+                                              <p:pRg st="6" end="6"/>
+                                            </p:txEl>
+                                          </p:spTgt>
+                                        </p:tgtEl>
+                                        <p:attrNameLst>
+                                          <p:attrName>style.visibility</p:attrName>
+                                        </p:attrNameLst>
+                                      </p:cBhvr>
+                                      <p:to>
+                                        <p:strVal val="visible"/>
+                                      </p:to>
+                                    </p:set>
+                                  </p:childTnLst>
+                                </p:cTn>
+                              </p:par>
+                            </p:childTnLst>
+                          </p:cTn>
+                        </p:par>
+                      </p:childTnLst>
+                    </p:cTn>
+                  </p:par>
+                </p:childTnLst>
+              </p:cTn>
+              <p:prevCondLst>
+                <p:cond evt="onPrev" delay="0">
+                  <p:tgtEl>
+                    <p:sldTgt/>
+                  </p:tgtEl>
+                </p:cond>
+              </p:prevCondLst>
+              <p:nextCondLst>
+                <p:cond evt="onNext" delay="0">
+                  <p:tgtEl>
+                    <p:sldTgt/>
+                  </p:tgtEl>
+                </p:cond>
+              </p:nextCondLst>
+            </p:seq>
+          </p:childTnLst>
+        </p:cTn>
+      </p:par>
+    </p:tnLst>
+    <p:bldLst>
+      <p:bldP spid="3" grpId="0" uiExpand="1" build="p"/>
+    </p:bldLst>
+  </p:timing>
 </p:sld>
 </file>
 
@@ -6483,110 +8071,224 @@
           </a:p>
         </p:txBody>
       </p:sp>
-      <p:sp>
-        <p:nvSpPr>
-          <p:cNvPr id="3" name="Content Placeholder 2">
-            <a:extLst>
-              <a:ext uri="{FF2B5EF4-FFF2-40B4-BE49-F238E27FC236}">
-                <a16:creationId xmlns:a16="http://schemas.microsoft.com/office/drawing/2014/main" id="{3948370B-BFEB-97A6-8784-4BB58F89EB16}"/>
-              </a:ext>
-            </a:extLst>
-          </p:cNvPr>
-          <p:cNvSpPr>
-            <a:spLocks noGrp="1"/>
-          </p:cNvSpPr>
-          <p:nvPr>
-            <p:ph idx="1"/>
-          </p:nvPr>
-        </p:nvSpPr>
-        <p:spPr/>
-        <p:txBody>
-          <a:bodyPr/>
-          <a:lstStyle/>
-          <a:p>
-            <a:pPr marL="971550" lvl="1" indent="-514350">
-              <a:buFont typeface="+mj-lt"/>
-              <a:buAutoNum type="arabicPeriod"/>
-            </a:pPr>
-            <a:r>
-              <a:rPr lang="en-GB" dirty="0"/>
-              <a:t>Start from input </a:t>
-            </a:r>
-            <a:r>
-              <a:rPr lang="en-GB" i="1" dirty="0"/>
-              <a:t>a</a:t>
-            </a:r>
-            <a:endParaRPr lang="en-GB" dirty="0"/>
-          </a:p>
-          <a:p>
-            <a:pPr marL="971550" lvl="1" indent="-514350">
-              <a:buFont typeface="+mj-lt"/>
-              <a:buAutoNum type="arabicPeriod"/>
-            </a:pPr>
-            <a:r>
-              <a:rPr lang="en-GB" dirty="0"/>
-              <a:t>Lift to higher dimension channel space by neural network </a:t>
-            </a:r>
-            <a:r>
-              <a:rPr lang="en-GB" i="1" dirty="0"/>
-              <a:t>P</a:t>
-            </a:r>
-            <a:endParaRPr lang="en-GB" dirty="0"/>
-          </a:p>
-          <a:p>
-            <a:pPr marL="971550" lvl="1" indent="-514350">
-              <a:buFont typeface="+mj-lt"/>
-              <a:buAutoNum type="arabicPeriod"/>
-            </a:pPr>
-            <a:r>
-              <a:rPr lang="en-GB" dirty="0"/>
-              <a:t>Apply multiple layers of integral operators and activation functions</a:t>
-            </a:r>
-          </a:p>
-          <a:p>
-            <a:pPr marL="971550" lvl="1" indent="-514350">
-              <a:buFont typeface="+mj-lt"/>
-              <a:buAutoNum type="arabicPeriod"/>
-            </a:pPr>
-            <a:r>
-              <a:rPr lang="en-GB" dirty="0"/>
-              <a:t>Project back to target dimension by neural network </a:t>
-            </a:r>
-            <a:r>
-              <a:rPr lang="en-GB" i="1" dirty="0"/>
-              <a:t>Q</a:t>
-            </a:r>
-            <a:endParaRPr lang="en-GB" dirty="0"/>
-          </a:p>
-          <a:p>
-            <a:pPr marL="971550" lvl="1" indent="-514350">
-              <a:buFont typeface="+mj-lt"/>
-              <a:buAutoNum type="arabicPeriod"/>
-            </a:pPr>
-            <a:r>
-              <a:rPr lang="en-GB" dirty="0"/>
-              <a:t>Output </a:t>
-            </a:r>
-            <a:r>
-              <a:rPr lang="en-GB" i="1" dirty="0"/>
-              <a:t>u</a:t>
-            </a:r>
-          </a:p>
-          <a:p>
-            <a:pPr marL="971550" lvl="1" indent="-514350">
-              <a:buFont typeface="+mj-lt"/>
-              <a:buAutoNum type="arabicPeriod"/>
-            </a:pPr>
-            <a:endParaRPr lang="en-GB" i="1" dirty="0"/>
-          </a:p>
-          <a:p>
-            <a:pPr marL="457200" lvl="1" indent="0">
-              <a:buNone/>
-            </a:pPr>
-            <a:endParaRPr lang="en-GB" i="1" dirty="0"/>
-          </a:p>
-        </p:txBody>
-      </p:sp>
+      <mc:AlternateContent xmlns:mc="http://schemas.openxmlformats.org/markup-compatibility/2006">
+        <mc:Choice xmlns:a14="http://schemas.microsoft.com/office/drawing/2010/main" Requires="a14">
+          <p:sp>
+            <p:nvSpPr>
+              <p:cNvPr id="3" name="Content Placeholder 2">
+                <a:extLst>
+                  <a:ext uri="{FF2B5EF4-FFF2-40B4-BE49-F238E27FC236}">
+                    <a16:creationId xmlns:a16="http://schemas.microsoft.com/office/drawing/2014/main" id="{3948370B-BFEB-97A6-8784-4BB58F89EB16}"/>
+                  </a:ext>
+                </a:extLst>
+              </p:cNvPr>
+              <p:cNvSpPr>
+                <a:spLocks noGrp="1"/>
+              </p:cNvSpPr>
+              <p:nvPr>
+                <p:ph idx="1"/>
+              </p:nvPr>
+            </p:nvSpPr>
+            <p:spPr/>
+            <p:txBody>
+              <a:bodyPr/>
+              <a:lstStyle/>
+              <a:p>
+                <a:pPr marL="971550" lvl="1" indent="-514350">
+                  <a:buFont typeface="+mj-lt"/>
+                  <a:buAutoNum type="arabicPeriod"/>
+                </a:pPr>
+                <a:r>
+                  <a:rPr lang="en-GB" dirty="0"/>
+                  <a:t>Start from input </a:t>
+                </a:r>
+                <a14:m>
+                  <m:oMath xmlns:m="http://schemas.openxmlformats.org/officeDocument/2006/math">
+                    <m:r>
+                      <m:rPr>
+                        <m:sty m:val="p"/>
+                      </m:rPr>
+                      <a:rPr lang="en-US" b="0" i="0" smtClean="0">
+                        <a:latin typeface="Cambria Math" panose="02040503050406030204" pitchFamily="18" charset="0"/>
+                      </a:rPr>
+                      <m:t>a</m:t>
+                    </m:r>
+                    <m:r>
+                      <a:rPr lang="en-US" b="0" i="0" smtClean="0">
+                        <a:latin typeface="Cambria Math" panose="02040503050406030204" pitchFamily="18" charset="0"/>
+                      </a:rPr>
+                      <m:t> </m:t>
+                    </m:r>
+                    <m:r>
+                      <a:rPr lang="en-US" b="0" i="1" smtClean="0">
+                        <a:latin typeface="Cambria Math" panose="02040503050406030204" pitchFamily="18" charset="0"/>
+                      </a:rPr>
+                      <m:t>𝜖</m:t>
+                    </m:r>
+                    <m:r>
+                      <a:rPr lang="en-US" b="0" i="1" smtClean="0">
+                        <a:latin typeface="Cambria Math" panose="02040503050406030204" pitchFamily="18" charset="0"/>
+                      </a:rPr>
+                      <m:t> </m:t>
+                    </m:r>
+                    <m:r>
+                      <a:rPr lang="en-US" b="0" i="1" smtClean="0">
+                        <a:latin typeface="Cambria Math" panose="02040503050406030204" pitchFamily="18" charset="0"/>
+                      </a:rPr>
+                      <m:t>𝒜</m:t>
+                    </m:r>
+                  </m:oMath>
+                </a14:m>
+                <a:endParaRPr lang="en-GB" dirty="0"/>
+              </a:p>
+              <a:p>
+                <a:pPr marL="971550" lvl="1" indent="-514350">
+                  <a:buFont typeface="+mj-lt"/>
+                  <a:buAutoNum type="arabicPeriod"/>
+                </a:pPr>
+                <a:r>
+                  <a:rPr lang="en-GB" dirty="0"/>
+                  <a:t>Lift to higher dimension channel space by neural network </a:t>
+                </a:r>
+                <a:r>
+                  <a:rPr lang="en-GB" i="1" dirty="0"/>
+                  <a:t>P</a:t>
+                </a:r>
+                <a:endParaRPr lang="en-GB" dirty="0"/>
+              </a:p>
+              <a:p>
+                <a:pPr marL="971550" lvl="1" indent="-514350">
+                  <a:buFont typeface="+mj-lt"/>
+                  <a:buAutoNum type="arabicPeriod"/>
+                </a:pPr>
+                <a:r>
+                  <a:rPr lang="en-GB" dirty="0"/>
+                  <a:t>Apply multiple layers of integral operators and activation functions</a:t>
+                </a:r>
+              </a:p>
+              <a:p>
+                <a:pPr marL="971550" lvl="1" indent="-514350">
+                  <a:buFont typeface="+mj-lt"/>
+                  <a:buAutoNum type="arabicPeriod"/>
+                </a:pPr>
+                <a:r>
+                  <a:rPr lang="en-GB" dirty="0"/>
+                  <a:t>Project back to target dimension by neural network </a:t>
+                </a:r>
+                <a:r>
+                  <a:rPr lang="en-GB" i="1" dirty="0"/>
+                  <a:t>Q</a:t>
+                </a:r>
+                <a:endParaRPr lang="en-GB" dirty="0"/>
+              </a:p>
+              <a:p>
+                <a:pPr marL="971550" lvl="1" indent="-514350">
+                  <a:buFont typeface="+mj-lt"/>
+                  <a:buAutoNum type="arabicPeriod"/>
+                </a:pPr>
+                <a:r>
+                  <a:rPr lang="en-GB" dirty="0"/>
+                  <a:t>Output </a:t>
+                </a:r>
+                <a14:m>
+                  <m:oMath xmlns:m="http://schemas.openxmlformats.org/officeDocument/2006/math">
+                    <m:r>
+                      <a:rPr lang="en-US" b="0" i="1" smtClean="0">
+                        <a:latin typeface="Cambria Math" panose="02040503050406030204" pitchFamily="18" charset="0"/>
+                      </a:rPr>
+                      <m:t>𝑢</m:t>
+                    </m:r>
+                    <m:r>
+                      <a:rPr lang="en-US" b="0" i="1" smtClean="0">
+                        <a:latin typeface="Cambria Math" panose="02040503050406030204" pitchFamily="18" charset="0"/>
+                      </a:rPr>
+                      <m:t> </m:t>
+                    </m:r>
+                    <m:r>
+                      <a:rPr lang="en-US" b="0" i="1" smtClean="0">
+                        <a:latin typeface="Cambria Math" panose="02040503050406030204" pitchFamily="18" charset="0"/>
+                      </a:rPr>
+                      <m:t>𝜖</m:t>
+                    </m:r>
+                    <m:r>
+                      <a:rPr lang="en-US" b="0" i="1" smtClean="0">
+                        <a:latin typeface="Cambria Math" panose="02040503050406030204" pitchFamily="18" charset="0"/>
+                      </a:rPr>
+                      <m:t> </m:t>
+                    </m:r>
+                    <m:r>
+                      <a:rPr lang="en-US" b="0" i="1" smtClean="0">
+                        <a:latin typeface="Cambria Math" panose="02040503050406030204" pitchFamily="18" charset="0"/>
+                      </a:rPr>
+                      <m:t>𝒰</m:t>
+                    </m:r>
+                  </m:oMath>
+                </a14:m>
+                <a:endParaRPr lang="en-US" b="0" dirty="0"/>
+              </a:p>
+              <a:p>
+                <a:pPr marL="971550" lvl="1" indent="-514350">
+                  <a:buFont typeface="+mj-lt"/>
+                  <a:buAutoNum type="arabicPeriod"/>
+                </a:pPr>
+                <a:endParaRPr lang="en-GB" i="1" dirty="0"/>
+              </a:p>
+              <a:p>
+                <a:pPr marL="971550" lvl="1" indent="-514350">
+                  <a:buFont typeface="+mj-lt"/>
+                  <a:buAutoNum type="arabicPeriod"/>
+                </a:pPr>
+                <a:endParaRPr lang="en-GB" i="1" dirty="0"/>
+              </a:p>
+              <a:p>
+                <a:pPr marL="457200" lvl="1" indent="0">
+                  <a:buNone/>
+                </a:pPr>
+                <a:endParaRPr lang="en-GB" i="1" dirty="0"/>
+              </a:p>
+            </p:txBody>
+          </p:sp>
+        </mc:Choice>
+        <mc:Fallback>
+          <p:sp>
+            <p:nvSpPr>
+              <p:cNvPr id="3" name="Content Placeholder 2">
+                <a:extLst>
+                  <a:ext uri="{FF2B5EF4-FFF2-40B4-BE49-F238E27FC236}">
+                    <a16:creationId xmlns:a16="http://schemas.microsoft.com/office/drawing/2014/main" id="{3948370B-BFEB-97A6-8784-4BB58F89EB16}"/>
+                  </a:ext>
+                </a:extLst>
+              </p:cNvPr>
+              <p:cNvSpPr>
+                <a:spLocks noGrp="1" noRot="1" noChangeAspect="1" noMove="1" noResize="1" noEditPoints="1" noAdjustHandles="1" noChangeArrowheads="1" noChangeShapeType="1" noTextEdit="1"/>
+              </p:cNvSpPr>
+              <p:nvPr>
+                <p:ph idx="1"/>
+              </p:nvPr>
+            </p:nvSpPr>
+            <p:spPr>
+              <a:blipFill>
+                <a:blip r:embed="rId2"/>
+                <a:stretch>
+                  <a:fillRect t="-1961"/>
+                </a:stretch>
+              </a:blipFill>
+            </p:spPr>
+            <p:txBody>
+              <a:bodyPr/>
+              <a:lstStyle/>
+              <a:p>
+                <a:r>
+                  <a:rPr lang="en-GB">
+                    <a:noFill/>
+                  </a:rPr>
+                  <a:t> </a:t>
+                </a:r>
+              </a:p>
+            </p:txBody>
+          </p:sp>
+        </mc:Fallback>
+      </mc:AlternateContent>
       <p:pic>
         <p:nvPicPr>
           <p:cNvPr id="5" name="Picture 4">
@@ -6602,7 +8304,7 @@
           <p:nvPr/>
         </p:nvPicPr>
         <p:blipFill>
-          <a:blip r:embed="rId2"/>
+          <a:blip r:embed="rId3"/>
           <a:stretch>
             <a:fillRect/>
           </a:stretch>
@@ -7242,6 +8944,257 @@
   <p:clrMapOvr>
     <a:masterClrMapping/>
   </p:clrMapOvr>
+  <p:timing>
+    <p:tnLst>
+      <p:par>
+        <p:cTn id="1" dur="indefinite" restart="never" nodeType="tmRoot">
+          <p:childTnLst>
+            <p:seq concurrent="1" nextAc="seek">
+              <p:cTn id="2" dur="indefinite" nodeType="mainSeq">
+                <p:childTnLst>
+                  <p:par>
+                    <p:cTn id="3" fill="hold">
+                      <p:stCondLst>
+                        <p:cond delay="indefinite"/>
+                      </p:stCondLst>
+                      <p:childTnLst>
+                        <p:par>
+                          <p:cTn id="4" fill="hold">
+                            <p:stCondLst>
+                              <p:cond delay="0"/>
+                            </p:stCondLst>
+                            <p:childTnLst>
+                              <p:par>
+                                <p:cTn id="5" presetID="1" presetClass="entr" presetSubtype="0" fill="hold" grpId="0" nodeType="clickEffect">
+                                  <p:stCondLst>
+                                    <p:cond delay="0"/>
+                                  </p:stCondLst>
+                                  <p:childTnLst>
+                                    <p:set>
+                                      <p:cBhvr>
+                                        <p:cTn id="6" dur="1" fill="hold">
+                                          <p:stCondLst>
+                                            <p:cond delay="0"/>
+                                          </p:stCondLst>
+                                        </p:cTn>
+                                        <p:tgtEl>
+                                          <p:spTgt spid="3">
+                                            <p:txEl>
+                                              <p:pRg st="0" end="0"/>
+                                            </p:txEl>
+                                          </p:spTgt>
+                                        </p:tgtEl>
+                                        <p:attrNameLst>
+                                          <p:attrName>style.visibility</p:attrName>
+                                        </p:attrNameLst>
+                                      </p:cBhvr>
+                                      <p:to>
+                                        <p:strVal val="visible"/>
+                                      </p:to>
+                                    </p:set>
+                                  </p:childTnLst>
+                                </p:cTn>
+                              </p:par>
+                              <p:par>
+                                <p:cTn id="7" presetID="1" presetClass="entr" presetSubtype="0" fill="hold" grpId="0" nodeType="withEffect">
+                                  <p:stCondLst>
+                                    <p:cond delay="0"/>
+                                  </p:stCondLst>
+                                  <p:childTnLst>
+                                    <p:set>
+                                      <p:cBhvr>
+                                        <p:cTn id="8" dur="1" fill="hold">
+                                          <p:stCondLst>
+                                            <p:cond delay="0"/>
+                                          </p:stCondLst>
+                                        </p:cTn>
+                                        <p:tgtEl>
+                                          <p:spTgt spid="3">
+                                            <p:txEl>
+                                              <p:pRg st="1" end="1"/>
+                                            </p:txEl>
+                                          </p:spTgt>
+                                        </p:tgtEl>
+                                        <p:attrNameLst>
+                                          <p:attrName>style.visibility</p:attrName>
+                                        </p:attrNameLst>
+                                      </p:cBhvr>
+                                      <p:to>
+                                        <p:strVal val="visible"/>
+                                      </p:to>
+                                    </p:set>
+                                  </p:childTnLst>
+                                </p:cTn>
+                              </p:par>
+                              <p:par>
+                                <p:cTn id="9" presetID="1" presetClass="entr" presetSubtype="0" fill="hold" nodeType="withEffect">
+                                  <p:stCondLst>
+                                    <p:cond delay="0"/>
+                                  </p:stCondLst>
+                                  <p:childTnLst>
+                                    <p:set>
+                                      <p:cBhvr>
+                                        <p:cTn id="10" dur="1" fill="hold">
+                                          <p:stCondLst>
+                                            <p:cond delay="0"/>
+                                          </p:stCondLst>
+                                        </p:cTn>
+                                        <p:tgtEl>
+                                          <p:spTgt spid="10"/>
+                                        </p:tgtEl>
+                                        <p:attrNameLst>
+                                          <p:attrName>style.visibility</p:attrName>
+                                        </p:attrNameLst>
+                                      </p:cBhvr>
+                                      <p:to>
+                                        <p:strVal val="visible"/>
+                                      </p:to>
+                                    </p:set>
+                                  </p:childTnLst>
+                                </p:cTn>
+                              </p:par>
+                            </p:childTnLst>
+                          </p:cTn>
+                        </p:par>
+                      </p:childTnLst>
+                    </p:cTn>
+                  </p:par>
+                  <p:par>
+                    <p:cTn id="11" fill="hold">
+                      <p:stCondLst>
+                        <p:cond delay="indefinite"/>
+                      </p:stCondLst>
+                      <p:childTnLst>
+                        <p:par>
+                          <p:cTn id="12" fill="hold">
+                            <p:stCondLst>
+                              <p:cond delay="0"/>
+                            </p:stCondLst>
+                            <p:childTnLst>
+                              <p:par>
+                                <p:cTn id="13" presetID="1" presetClass="entr" presetSubtype="0" fill="hold" grpId="0" nodeType="clickEffect">
+                                  <p:stCondLst>
+                                    <p:cond delay="0"/>
+                                  </p:stCondLst>
+                                  <p:childTnLst>
+                                    <p:set>
+                                      <p:cBhvr>
+                                        <p:cTn id="14" dur="1" fill="hold">
+                                          <p:stCondLst>
+                                            <p:cond delay="0"/>
+                                          </p:stCondLst>
+                                        </p:cTn>
+                                        <p:tgtEl>
+                                          <p:spTgt spid="3">
+                                            <p:txEl>
+                                              <p:pRg st="6" end="6"/>
+                                            </p:txEl>
+                                          </p:spTgt>
+                                        </p:tgtEl>
+                                        <p:attrNameLst>
+                                          <p:attrName>style.visibility</p:attrName>
+                                        </p:attrNameLst>
+                                      </p:cBhvr>
+                                      <p:to>
+                                        <p:strVal val="visible"/>
+                                      </p:to>
+                                    </p:set>
+                                  </p:childTnLst>
+                                </p:cTn>
+                              </p:par>
+                              <p:par>
+                                <p:cTn id="15" presetID="1" presetClass="entr" presetSubtype="0" fill="hold" grpId="0" nodeType="withEffect">
+                                  <p:stCondLst>
+                                    <p:cond delay="0"/>
+                                  </p:stCondLst>
+                                  <p:childTnLst>
+                                    <p:set>
+                                      <p:cBhvr>
+                                        <p:cTn id="16" dur="1" fill="hold">
+                                          <p:stCondLst>
+                                            <p:cond delay="0"/>
+                                          </p:stCondLst>
+                                        </p:cTn>
+                                        <p:tgtEl>
+                                          <p:spTgt spid="3">
+                                            <p:txEl>
+                                              <p:pRg st="7" end="7"/>
+                                            </p:txEl>
+                                          </p:spTgt>
+                                        </p:tgtEl>
+                                        <p:attrNameLst>
+                                          <p:attrName>style.visibility</p:attrName>
+                                        </p:attrNameLst>
+                                      </p:cBhvr>
+                                      <p:to>
+                                        <p:strVal val="visible"/>
+                                      </p:to>
+                                    </p:set>
+                                  </p:childTnLst>
+                                </p:cTn>
+                              </p:par>
+                              <p:par>
+                                <p:cTn id="17" presetID="1" presetClass="entr" presetSubtype="0" fill="hold" grpId="0" nodeType="withEffect">
+                                  <p:stCondLst>
+                                    <p:cond delay="0"/>
+                                  </p:stCondLst>
+                                  <p:childTnLst>
+                                    <p:set>
+                                      <p:cBhvr>
+                                        <p:cTn id="18" dur="1" fill="hold">
+                                          <p:stCondLst>
+                                            <p:cond delay="0"/>
+                                          </p:stCondLst>
+                                        </p:cTn>
+                                        <p:tgtEl>
+                                          <p:spTgt spid="3">
+                                            <p:txEl>
+                                              <p:pRg st="8" end="8"/>
+                                            </p:txEl>
+                                          </p:spTgt>
+                                        </p:tgtEl>
+                                        <p:attrNameLst>
+                                          <p:attrName>style.visibility</p:attrName>
+                                        </p:attrNameLst>
+                                      </p:cBhvr>
+                                      <p:to>
+                                        <p:strVal val="visible"/>
+                                      </p:to>
+                                    </p:set>
+                                  </p:childTnLst>
+                                </p:cTn>
+                              </p:par>
+                            </p:childTnLst>
+                          </p:cTn>
+                        </p:par>
+                      </p:childTnLst>
+                    </p:cTn>
+                  </p:par>
+                </p:childTnLst>
+              </p:cTn>
+              <p:prevCondLst>
+                <p:cond evt="onPrev" delay="0">
+                  <p:tgtEl>
+                    <p:sldTgt/>
+                  </p:tgtEl>
+                </p:cond>
+              </p:prevCondLst>
+              <p:nextCondLst>
+                <p:cond evt="onNext" delay="0">
+                  <p:tgtEl>
+                    <p:sldTgt/>
+                  </p:tgtEl>
+                </p:cond>
+              </p:nextCondLst>
+            </p:seq>
+          </p:childTnLst>
+        </p:cTn>
+      </p:par>
+    </p:tnLst>
+    <p:bldLst>
+      <p:bldP spid="3" grpId="0" uiExpand="1" build="p"/>
+    </p:bldLst>
+  </p:timing>
 </p:sld>
 </file>
 
@@ -7457,6 +9410,341 @@
   <p:clrMapOvr>
     <a:masterClrMapping/>
   </p:clrMapOvr>
+  <p:timing>
+    <p:tnLst>
+      <p:par>
+        <p:cTn id="1" dur="indefinite" restart="never" nodeType="tmRoot">
+          <p:childTnLst>
+            <p:seq concurrent="1" nextAc="seek">
+              <p:cTn id="2" dur="indefinite" nodeType="mainSeq">
+                <p:childTnLst>
+                  <p:par>
+                    <p:cTn id="3" fill="hold">
+                      <p:stCondLst>
+                        <p:cond delay="indefinite"/>
+                      </p:stCondLst>
+                      <p:childTnLst>
+                        <p:par>
+                          <p:cTn id="4" fill="hold">
+                            <p:stCondLst>
+                              <p:cond delay="0"/>
+                            </p:stCondLst>
+                            <p:childTnLst>
+                              <p:par>
+                                <p:cTn id="5" presetID="1" presetClass="entr" presetSubtype="0" fill="hold" grpId="0" nodeType="clickEffect">
+                                  <p:stCondLst>
+                                    <p:cond delay="0"/>
+                                  </p:stCondLst>
+                                  <p:childTnLst>
+                                    <p:set>
+                                      <p:cBhvr>
+                                        <p:cTn id="6" dur="1" fill="hold">
+                                          <p:stCondLst>
+                                            <p:cond delay="0"/>
+                                          </p:stCondLst>
+                                        </p:cTn>
+                                        <p:tgtEl>
+                                          <p:spTgt spid="3">
+                                            <p:txEl>
+                                              <p:pRg st="0" end="0"/>
+                                            </p:txEl>
+                                          </p:spTgt>
+                                        </p:tgtEl>
+                                        <p:attrNameLst>
+                                          <p:attrName>style.visibility</p:attrName>
+                                        </p:attrNameLst>
+                                      </p:cBhvr>
+                                      <p:to>
+                                        <p:strVal val="visible"/>
+                                      </p:to>
+                                    </p:set>
+                                  </p:childTnLst>
+                                </p:cTn>
+                              </p:par>
+                              <p:par>
+                                <p:cTn id="7" presetID="1" presetClass="entr" presetSubtype="0" fill="hold" grpId="0" nodeType="withEffect">
+                                  <p:stCondLst>
+                                    <p:cond delay="0"/>
+                                  </p:stCondLst>
+                                  <p:childTnLst>
+                                    <p:set>
+                                      <p:cBhvr>
+                                        <p:cTn id="8" dur="1" fill="hold">
+                                          <p:stCondLst>
+                                            <p:cond delay="0"/>
+                                          </p:stCondLst>
+                                        </p:cTn>
+                                        <p:tgtEl>
+                                          <p:spTgt spid="3">
+                                            <p:txEl>
+                                              <p:pRg st="1" end="1"/>
+                                            </p:txEl>
+                                          </p:spTgt>
+                                        </p:tgtEl>
+                                        <p:attrNameLst>
+                                          <p:attrName>style.visibility</p:attrName>
+                                        </p:attrNameLst>
+                                      </p:cBhvr>
+                                      <p:to>
+                                        <p:strVal val="visible"/>
+                                      </p:to>
+                                    </p:set>
+                                  </p:childTnLst>
+                                </p:cTn>
+                              </p:par>
+                            </p:childTnLst>
+                          </p:cTn>
+                        </p:par>
+                      </p:childTnLst>
+                    </p:cTn>
+                  </p:par>
+                  <p:par>
+                    <p:cTn id="9" fill="hold">
+                      <p:stCondLst>
+                        <p:cond delay="indefinite"/>
+                      </p:stCondLst>
+                      <p:childTnLst>
+                        <p:par>
+                          <p:cTn id="10" fill="hold">
+                            <p:stCondLst>
+                              <p:cond delay="0"/>
+                            </p:stCondLst>
+                            <p:childTnLst>
+                              <p:par>
+                                <p:cTn id="11" presetID="1" presetClass="entr" presetSubtype="0" fill="hold" grpId="0" nodeType="clickEffect">
+                                  <p:stCondLst>
+                                    <p:cond delay="0"/>
+                                  </p:stCondLst>
+                                  <p:childTnLst>
+                                    <p:set>
+                                      <p:cBhvr>
+                                        <p:cTn id="12" dur="1" fill="hold">
+                                          <p:stCondLst>
+                                            <p:cond delay="0"/>
+                                          </p:stCondLst>
+                                        </p:cTn>
+                                        <p:tgtEl>
+                                          <p:spTgt spid="3">
+                                            <p:txEl>
+                                              <p:pRg st="3" end="3"/>
+                                            </p:txEl>
+                                          </p:spTgt>
+                                        </p:tgtEl>
+                                        <p:attrNameLst>
+                                          <p:attrName>style.visibility</p:attrName>
+                                        </p:attrNameLst>
+                                      </p:cBhvr>
+                                      <p:to>
+                                        <p:strVal val="visible"/>
+                                      </p:to>
+                                    </p:set>
+                                  </p:childTnLst>
+                                </p:cTn>
+                              </p:par>
+                              <p:par>
+                                <p:cTn id="13" presetID="1" presetClass="entr" presetSubtype="0" fill="hold" grpId="0" nodeType="withEffect">
+                                  <p:stCondLst>
+                                    <p:cond delay="0"/>
+                                  </p:stCondLst>
+                                  <p:childTnLst>
+                                    <p:set>
+                                      <p:cBhvr>
+                                        <p:cTn id="14" dur="1" fill="hold">
+                                          <p:stCondLst>
+                                            <p:cond delay="0"/>
+                                          </p:stCondLst>
+                                        </p:cTn>
+                                        <p:tgtEl>
+                                          <p:spTgt spid="3">
+                                            <p:txEl>
+                                              <p:pRg st="4" end="4"/>
+                                            </p:txEl>
+                                          </p:spTgt>
+                                        </p:tgtEl>
+                                        <p:attrNameLst>
+                                          <p:attrName>style.visibility</p:attrName>
+                                        </p:attrNameLst>
+                                      </p:cBhvr>
+                                      <p:to>
+                                        <p:strVal val="visible"/>
+                                      </p:to>
+                                    </p:set>
+                                  </p:childTnLst>
+                                </p:cTn>
+                              </p:par>
+                            </p:childTnLst>
+                          </p:cTn>
+                        </p:par>
+                      </p:childTnLst>
+                    </p:cTn>
+                  </p:par>
+                  <p:par>
+                    <p:cTn id="15" fill="hold">
+                      <p:stCondLst>
+                        <p:cond delay="indefinite"/>
+                      </p:stCondLst>
+                      <p:childTnLst>
+                        <p:par>
+                          <p:cTn id="16" fill="hold">
+                            <p:stCondLst>
+                              <p:cond delay="0"/>
+                            </p:stCondLst>
+                            <p:childTnLst>
+                              <p:par>
+                                <p:cTn id="17" presetID="1" presetClass="entr" presetSubtype="0" fill="hold" grpId="0" nodeType="clickEffect">
+                                  <p:stCondLst>
+                                    <p:cond delay="0"/>
+                                  </p:stCondLst>
+                                  <p:childTnLst>
+                                    <p:set>
+                                      <p:cBhvr>
+                                        <p:cTn id="18" dur="1" fill="hold">
+                                          <p:stCondLst>
+                                            <p:cond delay="0"/>
+                                          </p:stCondLst>
+                                        </p:cTn>
+                                        <p:tgtEl>
+                                          <p:spTgt spid="3">
+                                            <p:txEl>
+                                              <p:pRg st="6" end="6"/>
+                                            </p:txEl>
+                                          </p:spTgt>
+                                        </p:tgtEl>
+                                        <p:attrNameLst>
+                                          <p:attrName>style.visibility</p:attrName>
+                                        </p:attrNameLst>
+                                      </p:cBhvr>
+                                      <p:to>
+                                        <p:strVal val="visible"/>
+                                      </p:to>
+                                    </p:set>
+                                  </p:childTnLst>
+                                </p:cTn>
+                              </p:par>
+                              <p:par>
+                                <p:cTn id="19" presetID="1" presetClass="entr" presetSubtype="0" fill="hold" grpId="0" nodeType="withEffect">
+                                  <p:stCondLst>
+                                    <p:cond delay="0"/>
+                                  </p:stCondLst>
+                                  <p:childTnLst>
+                                    <p:set>
+                                      <p:cBhvr>
+                                        <p:cTn id="20" dur="1" fill="hold">
+                                          <p:stCondLst>
+                                            <p:cond delay="0"/>
+                                          </p:stCondLst>
+                                        </p:cTn>
+                                        <p:tgtEl>
+                                          <p:spTgt spid="3">
+                                            <p:txEl>
+                                              <p:pRg st="7" end="7"/>
+                                            </p:txEl>
+                                          </p:spTgt>
+                                        </p:tgtEl>
+                                        <p:attrNameLst>
+                                          <p:attrName>style.visibility</p:attrName>
+                                        </p:attrNameLst>
+                                      </p:cBhvr>
+                                      <p:to>
+                                        <p:strVal val="visible"/>
+                                      </p:to>
+                                    </p:set>
+                                  </p:childTnLst>
+                                </p:cTn>
+                              </p:par>
+                              <p:par>
+                                <p:cTn id="21" presetID="1" presetClass="entr" presetSubtype="0" fill="hold" grpId="0" nodeType="withEffect">
+                                  <p:stCondLst>
+                                    <p:cond delay="0"/>
+                                  </p:stCondLst>
+                                  <p:childTnLst>
+                                    <p:set>
+                                      <p:cBhvr>
+                                        <p:cTn id="22" dur="1" fill="hold">
+                                          <p:stCondLst>
+                                            <p:cond delay="0"/>
+                                          </p:stCondLst>
+                                        </p:cTn>
+                                        <p:tgtEl>
+                                          <p:spTgt spid="3">
+                                            <p:txEl>
+                                              <p:pRg st="8" end="8"/>
+                                            </p:txEl>
+                                          </p:spTgt>
+                                        </p:tgtEl>
+                                        <p:attrNameLst>
+                                          <p:attrName>style.visibility</p:attrName>
+                                        </p:attrNameLst>
+                                      </p:cBhvr>
+                                      <p:to>
+                                        <p:strVal val="visible"/>
+                                      </p:to>
+                                    </p:set>
+                                  </p:childTnLst>
+                                </p:cTn>
+                              </p:par>
+                              <p:par>
+                                <p:cTn id="23" presetID="1" presetClass="entr" presetSubtype="0" fill="hold" grpId="0" nodeType="withEffect">
+                                  <p:stCondLst>
+                                    <p:cond delay="0"/>
+                                  </p:stCondLst>
+                                  <p:childTnLst>
+                                    <p:set>
+                                      <p:cBhvr>
+                                        <p:cTn id="24" dur="1" fill="hold">
+                                          <p:stCondLst>
+                                            <p:cond delay="0"/>
+                                          </p:stCondLst>
+                                        </p:cTn>
+                                        <p:tgtEl>
+                                          <p:spTgt spid="3">
+                                            <p:txEl>
+                                              <p:pRg st="9" end="9"/>
+                                            </p:txEl>
+                                          </p:spTgt>
+                                        </p:tgtEl>
+                                        <p:attrNameLst>
+                                          <p:attrName>style.visibility</p:attrName>
+                                        </p:attrNameLst>
+                                      </p:cBhvr>
+                                      <p:to>
+                                        <p:strVal val="visible"/>
+                                      </p:to>
+                                    </p:set>
+                                  </p:childTnLst>
+                                </p:cTn>
+                              </p:par>
+                            </p:childTnLst>
+                          </p:cTn>
+                        </p:par>
+                      </p:childTnLst>
+                    </p:cTn>
+                  </p:par>
+                </p:childTnLst>
+              </p:cTn>
+              <p:prevCondLst>
+                <p:cond evt="onPrev" delay="0">
+                  <p:tgtEl>
+                    <p:sldTgt/>
+                  </p:tgtEl>
+                </p:cond>
+              </p:prevCondLst>
+              <p:nextCondLst>
+                <p:cond evt="onNext" delay="0">
+                  <p:tgtEl>
+                    <p:sldTgt/>
+                  </p:tgtEl>
+                </p:cond>
+              </p:nextCondLst>
+            </p:seq>
+          </p:childTnLst>
+        </p:cTn>
+      </p:par>
+    </p:tnLst>
+    <p:bldLst>
+      <p:bldP spid="3" grpId="0" build="p"/>
+    </p:bldLst>
+  </p:timing>
 </p:sld>
 </file>
 
@@ -7505,8 +9793,8 @@
           </a:p>
         </p:txBody>
       </p:sp>
-      <mc:AlternateContent xmlns:mc="http://schemas.openxmlformats.org/markup-compatibility/2006" xmlns:a14="http://schemas.microsoft.com/office/drawing/2010/main">
-        <mc:Choice Requires="a14">
+      <mc:AlternateContent xmlns:mc="http://schemas.openxmlformats.org/markup-compatibility/2006">
+        <mc:Choice xmlns:a14="http://schemas.microsoft.com/office/drawing/2010/main" Requires="a14">
           <p:sp>
             <p:nvSpPr>
               <p:cNvPr id="3" name="Content Placeholder 2">
@@ -7533,7 +9821,7 @@
                 </a:pPr>
                 <a:r>
                   <a:rPr lang="en-GB" dirty="0"/>
-                  <a:t>Estimate the solution to Navier-Stokes equation given sparse data in spatial and time domain</a:t>
+                  <a:t>Estimate the solution to Navier-Stokes equation given sparse data in spatial and time domains</a:t>
                 </a:r>
               </a:p>
               <a:p>
@@ -7707,7 +9995,7 @@
             </p:txBody>
           </p:sp>
         </mc:Choice>
-        <mc:Fallback xmlns="">
+        <mc:Fallback>
           <p:sp>
             <p:nvSpPr>
               <p:cNvPr id="3" name="Content Placeholder 2">
@@ -7787,6 +10075,244 @@
   <p:clrMapOvr>
     <a:masterClrMapping/>
   </p:clrMapOvr>
+  <p:timing>
+    <p:tnLst>
+      <p:par>
+        <p:cTn id="1" dur="indefinite" restart="never" nodeType="tmRoot">
+          <p:childTnLst>
+            <p:seq concurrent="1" nextAc="seek">
+              <p:cTn id="2" dur="indefinite" nodeType="mainSeq">
+                <p:childTnLst>
+                  <p:par>
+                    <p:cTn id="3" fill="hold">
+                      <p:stCondLst>
+                        <p:cond delay="indefinite"/>
+                      </p:stCondLst>
+                      <p:childTnLst>
+                        <p:par>
+                          <p:cTn id="4" fill="hold">
+                            <p:stCondLst>
+                              <p:cond delay="0"/>
+                            </p:stCondLst>
+                            <p:childTnLst>
+                              <p:par>
+                                <p:cTn id="5" presetID="1" presetClass="entr" presetSubtype="0" fill="hold" grpId="0" nodeType="clickEffect">
+                                  <p:stCondLst>
+                                    <p:cond delay="0"/>
+                                  </p:stCondLst>
+                                  <p:childTnLst>
+                                    <p:set>
+                                      <p:cBhvr>
+                                        <p:cTn id="6" dur="1" fill="hold">
+                                          <p:stCondLst>
+                                            <p:cond delay="0"/>
+                                          </p:stCondLst>
+                                        </p:cTn>
+                                        <p:tgtEl>
+                                          <p:spTgt spid="3">
+                                            <p:txEl>
+                                              <p:pRg st="0" end="0"/>
+                                            </p:txEl>
+                                          </p:spTgt>
+                                        </p:tgtEl>
+                                        <p:attrNameLst>
+                                          <p:attrName>style.visibility</p:attrName>
+                                        </p:attrNameLst>
+                                      </p:cBhvr>
+                                      <p:to>
+                                        <p:strVal val="visible"/>
+                                      </p:to>
+                                    </p:set>
+                                  </p:childTnLst>
+                                </p:cTn>
+                              </p:par>
+                            </p:childTnLst>
+                          </p:cTn>
+                        </p:par>
+                      </p:childTnLst>
+                    </p:cTn>
+                  </p:par>
+                  <p:par>
+                    <p:cTn id="7" fill="hold">
+                      <p:stCondLst>
+                        <p:cond delay="indefinite"/>
+                      </p:stCondLst>
+                      <p:childTnLst>
+                        <p:par>
+                          <p:cTn id="8" fill="hold">
+                            <p:stCondLst>
+                              <p:cond delay="0"/>
+                            </p:stCondLst>
+                            <p:childTnLst>
+                              <p:par>
+                                <p:cTn id="9" presetID="1" presetClass="entr" presetSubtype="0" fill="hold" grpId="0" nodeType="clickEffect">
+                                  <p:stCondLst>
+                                    <p:cond delay="0"/>
+                                  </p:stCondLst>
+                                  <p:childTnLst>
+                                    <p:set>
+                                      <p:cBhvr>
+                                        <p:cTn id="10" dur="1" fill="hold">
+                                          <p:stCondLst>
+                                            <p:cond delay="0"/>
+                                          </p:stCondLst>
+                                        </p:cTn>
+                                        <p:tgtEl>
+                                          <p:spTgt spid="3">
+                                            <p:txEl>
+                                              <p:pRg st="1" end="1"/>
+                                            </p:txEl>
+                                          </p:spTgt>
+                                        </p:tgtEl>
+                                        <p:attrNameLst>
+                                          <p:attrName>style.visibility</p:attrName>
+                                        </p:attrNameLst>
+                                      </p:cBhvr>
+                                      <p:to>
+                                        <p:strVal val="visible"/>
+                                      </p:to>
+                                    </p:set>
+                                  </p:childTnLst>
+                                </p:cTn>
+                              </p:par>
+                              <p:par>
+                                <p:cTn id="11" presetID="1" presetClass="entr" presetSubtype="0" fill="hold" grpId="0" nodeType="withEffect">
+                                  <p:stCondLst>
+                                    <p:cond delay="0"/>
+                                  </p:stCondLst>
+                                  <p:childTnLst>
+                                    <p:set>
+                                      <p:cBhvr>
+                                        <p:cTn id="12" dur="1" fill="hold">
+                                          <p:stCondLst>
+                                            <p:cond delay="0"/>
+                                          </p:stCondLst>
+                                        </p:cTn>
+                                        <p:tgtEl>
+                                          <p:spTgt spid="3">
+                                            <p:txEl>
+                                              <p:pRg st="2" end="2"/>
+                                            </p:txEl>
+                                          </p:spTgt>
+                                        </p:tgtEl>
+                                        <p:attrNameLst>
+                                          <p:attrName>style.visibility</p:attrName>
+                                        </p:attrNameLst>
+                                      </p:cBhvr>
+                                      <p:to>
+                                        <p:strVal val="visible"/>
+                                      </p:to>
+                                    </p:set>
+                                  </p:childTnLst>
+                                </p:cTn>
+                              </p:par>
+                              <p:par>
+                                <p:cTn id="13" presetID="1" presetClass="entr" presetSubtype="0" fill="hold" grpId="0" nodeType="withEffect">
+                                  <p:stCondLst>
+                                    <p:cond delay="0"/>
+                                  </p:stCondLst>
+                                  <p:childTnLst>
+                                    <p:set>
+                                      <p:cBhvr>
+                                        <p:cTn id="14" dur="1" fill="hold">
+                                          <p:stCondLst>
+                                            <p:cond delay="0"/>
+                                          </p:stCondLst>
+                                        </p:cTn>
+                                        <p:tgtEl>
+                                          <p:spTgt spid="3">
+                                            <p:txEl>
+                                              <p:pRg st="3" end="3"/>
+                                            </p:txEl>
+                                          </p:spTgt>
+                                        </p:tgtEl>
+                                        <p:attrNameLst>
+                                          <p:attrName>style.visibility</p:attrName>
+                                        </p:attrNameLst>
+                                      </p:cBhvr>
+                                      <p:to>
+                                        <p:strVal val="visible"/>
+                                      </p:to>
+                                    </p:set>
+                                  </p:childTnLst>
+                                </p:cTn>
+                              </p:par>
+                            </p:childTnLst>
+                          </p:cTn>
+                        </p:par>
+                      </p:childTnLst>
+                    </p:cTn>
+                  </p:par>
+                  <p:par>
+                    <p:cTn id="15" fill="hold">
+                      <p:stCondLst>
+                        <p:cond delay="indefinite"/>
+                      </p:stCondLst>
+                      <p:childTnLst>
+                        <p:par>
+                          <p:cTn id="16" fill="hold">
+                            <p:stCondLst>
+                              <p:cond delay="0"/>
+                            </p:stCondLst>
+                            <p:childTnLst>
+                              <p:par>
+                                <p:cTn id="17" presetID="1" presetClass="entr" presetSubtype="0" fill="hold" nodeType="clickEffect">
+                                  <p:stCondLst>
+                                    <p:cond delay="0"/>
+                                  </p:stCondLst>
+                                  <p:childTnLst>
+                                    <p:set>
+                                      <p:cBhvr>
+                                        <p:cTn id="18" dur="1" fill="hold">
+                                          <p:stCondLst>
+                                            <p:cond delay="0"/>
+                                          </p:stCondLst>
+                                        </p:cTn>
+                                        <p:tgtEl>
+                                          <p:spTgt spid="5"/>
+                                        </p:tgtEl>
+                                        <p:attrNameLst>
+                                          <p:attrName>style.visibility</p:attrName>
+                                        </p:attrNameLst>
+                                      </p:cBhvr>
+                                      <p:to>
+                                        <p:strVal val="visible"/>
+                                      </p:to>
+                                    </p:set>
+                                  </p:childTnLst>
+                                </p:cTn>
+                              </p:par>
+                            </p:childTnLst>
+                          </p:cTn>
+                        </p:par>
+                      </p:childTnLst>
+                    </p:cTn>
+                  </p:par>
+                </p:childTnLst>
+              </p:cTn>
+              <p:prevCondLst>
+                <p:cond evt="onPrev" delay="0">
+                  <p:tgtEl>
+                    <p:sldTgt/>
+                  </p:tgtEl>
+                </p:cond>
+              </p:prevCondLst>
+              <p:nextCondLst>
+                <p:cond evt="onNext" delay="0">
+                  <p:tgtEl>
+                    <p:sldTgt/>
+                  </p:tgtEl>
+                </p:cond>
+              </p:nextCondLst>
+            </p:seq>
+          </p:childTnLst>
+        </p:cTn>
+      </p:par>
+    </p:tnLst>
+    <p:bldLst>
+      <p:bldP spid="3" grpId="0" uiExpand="1" build="p"/>
+    </p:bldLst>
+  </p:timing>
 </p:sld>
 </file>
 

</xml_diff>